<commit_message>
📰 Pulse update 2026-03-14
</commit_message>
<xml_diff>
--- a/data/archive/pulse_2026-03-14.pptx
+++ b/data/archive/pulse_2026-03-14.pptx
@@ -23,6 +23,8 @@
     <p:sldId id="271" r:id="rId22"/>
     <p:sldId id="272" r:id="rId23"/>
     <p:sldId id="273" r:id="rId24"/>
+    <p:sldId id="274" r:id="rId25"/>
+    <p:sldId id="275" r:id="rId26"/>
   </p:sldIdLst>
   <p:sldSz cx="12191695" cy="6858000" type="screen4x3"/>
   <p:notesSz cx="6858000" cy="9144000"/>
@@ -3305,7 +3307,7 @@
             <a:avLst/>
           </a:prstGeom>
           <a:solidFill>
-            <a:srgbClr val="AB47BC"/>
+            <a:srgbClr val="10B981"/>
           </a:solidFill>
           <a:ln>
             <a:noFill/>
@@ -3358,13 +3360,13 @@
             <a:pPr algn="l">
               <a:defRPr sz="1000" b="1">
                 <a:solidFill>
-                  <a:srgbClr val="AB47BC"/>
-                </a:solidFill>
-                <a:latin typeface="Calibri"/>
-              </a:defRPr>
-            </a:pPr>
-            <a:r>
-              <a:t>💡  OFFICE LIFE</a:t>
+                  <a:srgbClr val="10B981"/>
+                </a:solidFill>
+                <a:latin typeface="Calibri"/>
+              </a:defRPr>
+            </a:pPr>
+            <a:r>
+              <a:t>🚀  CLAPS</a:t>
             </a:r>
           </a:p>
         </p:txBody>
@@ -3394,13 +3396,13 @@
             <a:pPr algn="l">
               <a:defRPr sz="3200" b="1" i="0">
                 <a:solidFill>
-                  <a:srgbClr val="AB47BC"/>
-                </a:solidFill>
-                <a:latin typeface="Calibri"/>
-              </a:defRPr>
-            </a:pPr>
-            <a:r>
-              <a:t>Innovation Mindset</a:t>
+                  <a:srgbClr val="10B981"/>
+                </a:solidFill>
+                <a:latin typeface="Calibri"/>
+              </a:defRPr>
+            </a:pPr>
+            <a:r>
+              <a:t>Team Collaboration</a:t>
             </a:r>
           </a:p>
         </p:txBody>
@@ -3414,6 +3416,150 @@
         <p:spPr>
           <a:xfrm>
             <a:off x="1097280" y="2103120"/>
+            <a:ext cx="2743200" cy="548640"/>
+          </a:xfrm>
+          <a:prstGeom prst="rect">
+            <a:avLst/>
+          </a:prstGeom>
+          <a:noFill/>
+        </p:spPr>
+        <p:txBody>
+          <a:bodyPr wrap="square">
+            <a:spAutoFit/>
+          </a:bodyPr>
+          <a:lstStyle/>
+          <a:p>
+            <a:pPr algn="l">
+              <a:defRPr sz="2800" b="1" i="0">
+                <a:solidFill>
+                  <a:srgbClr val="10B981"/>
+                </a:solidFill>
+                <a:latin typeface="Calibri"/>
+              </a:defRPr>
+            </a:pPr>
+            <a:r>
+              <a:t>50</a:t>
+            </a:r>
+          </a:p>
+        </p:txBody>
+      </p:sp>
+      <p:sp>
+        <p:nvSpPr>
+          <p:cNvPr id="6" name="TextBox 5"/>
+          <p:cNvSpPr txBox="1"/>
+          <p:nvPr/>
+        </p:nvSpPr>
+        <p:spPr>
+          <a:xfrm>
+            <a:off x="1097280" y="2651760"/>
+            <a:ext cx="9966960" cy="365760"/>
+          </a:xfrm>
+          <a:prstGeom prst="rect">
+            <a:avLst/>
+          </a:prstGeom>
+          <a:noFill/>
+        </p:spPr>
+        <p:txBody>
+          <a:bodyPr wrap="square">
+            <a:spAutoFit/>
+          </a:bodyPr>
+          <a:lstStyle/>
+          <a:p>
+            <a:pPr algn="l">
+              <a:defRPr sz="1400" b="0" i="0">
+                <a:solidFill>
+                  <a:srgbClr val="E2E2EA"/>
+                </a:solidFill>
+                <a:latin typeface="Calibri"/>
+              </a:defRPr>
+            </a:pPr>
+            <a:r>
+              <a:t>from Michael Lotfy</a:t>
+            </a:r>
+          </a:p>
+        </p:txBody>
+      </p:sp>
+      <p:sp>
+        <p:nvSpPr>
+          <p:cNvPr id="7" name="TextBox 6"/>
+          <p:cNvSpPr txBox="1"/>
+          <p:nvPr/>
+        </p:nvSpPr>
+        <p:spPr>
+          <a:xfrm>
+            <a:off x="1097280" y="3108960"/>
+            <a:ext cx="9966960" cy="365760"/>
+          </a:xfrm>
+          <a:prstGeom prst="rect">
+            <a:avLst/>
+          </a:prstGeom>
+          <a:noFill/>
+        </p:spPr>
+        <p:txBody>
+          <a:bodyPr wrap="square">
+            <a:spAutoFit/>
+          </a:bodyPr>
+          <a:lstStyle/>
+          <a:p>
+            <a:pPr algn="l">
+              <a:defRPr sz="1400" b="1" i="0">
+                <a:solidFill>
+                  <a:srgbClr val="FFFFFF"/>
+                </a:solidFill>
+                <a:latin typeface="Calibri"/>
+              </a:defRPr>
+            </a:pPr>
+            <a:r>
+              <a:t>to: Isahakyan</a:t>
+            </a:r>
+          </a:p>
+        </p:txBody>
+      </p:sp>
+      <p:sp>
+        <p:nvSpPr>
+          <p:cNvPr id="8" name="TextBox 7"/>
+          <p:cNvSpPr txBox="1"/>
+          <p:nvPr/>
+        </p:nvSpPr>
+        <p:spPr>
+          <a:xfrm>
+            <a:off x="1097280" y="3749039"/>
+            <a:ext cx="9966960" cy="1097280"/>
+          </a:xfrm>
+          <a:prstGeom prst="rect">
+            <a:avLst/>
+          </a:prstGeom>
+          <a:noFill/>
+        </p:spPr>
+        <p:txBody>
+          <a:bodyPr wrap="square">
+            <a:spAutoFit/>
+          </a:bodyPr>
+          <a:lstStyle/>
+          <a:p>
+            <a:pPr algn="l">
+              <a:defRPr sz="1500" b="0" i="1">
+                <a:solidFill>
+                  <a:srgbClr val="E2E2EA"/>
+                </a:solidFill>
+                <a:latin typeface="Calibri"/>
+              </a:defRPr>
+            </a:pPr>
+            <a:r>
+              <a:t>"Exceptional teamwork and collaboration"</a:t>
+            </a:r>
+          </a:p>
+        </p:txBody>
+      </p:sp>
+      <p:sp>
+        <p:nvSpPr>
+          <p:cNvPr id="9" name="TextBox 8"/>
+          <p:cNvSpPr txBox="1"/>
+          <p:nvPr/>
+        </p:nvSpPr>
+        <p:spPr>
+          <a:xfrm>
+            <a:off x="1097280" y="5120640"/>
             <a:ext cx="9966960" cy="457200"/>
           </a:xfrm>
           <a:prstGeom prst="rect">
@@ -3428,159 +3574,15 @@
           <a:lstStyle/>
           <a:p>
             <a:pPr algn="l">
-              <a:defRPr sz="1800" b="1" i="0">
-                <a:solidFill>
-                  <a:srgbClr val="FFFFFF"/>
-                </a:solidFill>
-                <a:latin typeface="Calibri"/>
-              </a:defRPr>
-            </a:pPr>
-            <a:r>
-              <a:t>Build Fast, Learn Faster</a:t>
-            </a:r>
-          </a:p>
-        </p:txBody>
-      </p:sp>
-      <p:sp>
-        <p:nvSpPr>
-          <p:cNvPr id="6" name="TextBox 5"/>
-          <p:cNvSpPr txBox="1"/>
-          <p:nvPr/>
-        </p:nvSpPr>
-        <p:spPr>
-          <a:xfrm>
-            <a:off x="1371600" y="2743200"/>
-            <a:ext cx="9692640" cy="1828800"/>
-          </a:xfrm>
-          <a:prstGeom prst="rect">
-            <a:avLst/>
-          </a:prstGeom>
-          <a:noFill/>
-        </p:spPr>
-        <p:txBody>
-          <a:bodyPr wrap="square">
-            <a:spAutoFit/>
-          </a:bodyPr>
-          <a:lstStyle/>
-          <a:p>
-            <a:pPr algn="l">
-              <a:defRPr sz="1500" b="0" i="1">
-                <a:solidFill>
-                  <a:srgbClr val="E2E2EA"/>
-                </a:solidFill>
-                <a:latin typeface="Calibri"/>
-              </a:defRPr>
-            </a:pPr>
-            <a:r>
-              <a:t>"We're making great progress in building products, and it's especially exciting to see how quickly non-engineering teams have created so many useful tools. This is a strong sign that we're learning fast and moving in the right direction."</a:t>
-            </a:r>
-          </a:p>
-        </p:txBody>
-      </p:sp>
-      <p:sp>
-        <p:nvSpPr>
-          <p:cNvPr id="7" name="TextBox 6"/>
-          <p:cNvSpPr txBox="1"/>
-          <p:nvPr/>
-        </p:nvSpPr>
-        <p:spPr>
-          <a:xfrm>
-            <a:off x="1097280" y="4754880"/>
-            <a:ext cx="9966960" cy="365760"/>
-          </a:xfrm>
-          <a:prstGeom prst="rect">
-            <a:avLst/>
-          </a:prstGeom>
-          <a:noFill/>
-        </p:spPr>
-        <p:txBody>
-          <a:bodyPr wrap="square">
-            <a:spAutoFit/>
-          </a:bodyPr>
-          <a:lstStyle/>
-          <a:p>
-            <a:pPr algn="l">
-              <a:defRPr sz="1400" b="0" i="0">
-                <a:solidFill>
-                  <a:srgbClr val="8F95A3"/>
-                </a:solidFill>
-                <a:latin typeface="Calibri"/>
-              </a:defRPr>
-            </a:pPr>
-            <a:r>
-              <a:t>— Alexandr Zhitlukhin</a:t>
-            </a:r>
-          </a:p>
-        </p:txBody>
-      </p:sp>
-      <p:sp>
-        <p:nvSpPr>
-          <p:cNvPr id="8" name="TextBox 7"/>
-          <p:cNvSpPr txBox="1"/>
-          <p:nvPr/>
-        </p:nvSpPr>
-        <p:spPr>
-          <a:xfrm>
-            <a:off x="1097280" y="5212080"/>
-            <a:ext cx="9966960" cy="365760"/>
-          </a:xfrm>
-          <a:prstGeom prst="rect">
-            <a:avLst/>
-          </a:prstGeom>
-          <a:noFill/>
-        </p:spPr>
-        <p:txBody>
-          <a:bodyPr wrap="square">
-            <a:spAutoFit/>
-          </a:bodyPr>
-          <a:lstStyle/>
-          <a:p>
-            <a:pPr algn="l">
-              <a:defRPr sz="1400" b="1" i="0">
-                <a:solidFill>
-                  <a:srgbClr val="AB47BC"/>
-                </a:solidFill>
-                <a:latin typeface="Calibri"/>
-              </a:defRPr>
-            </a:pPr>
-            <a:r>
-              <a:t>59</a:t>
-            </a:r>
-          </a:p>
-        </p:txBody>
-      </p:sp>
-      <p:sp>
-        <p:nvSpPr>
-          <p:cNvPr id="9" name="TextBox 8"/>
-          <p:cNvSpPr txBox="1"/>
-          <p:nvPr/>
-        </p:nvSpPr>
-        <p:spPr>
-          <a:xfrm>
-            <a:off x="1097280" y="5760720"/>
-            <a:ext cx="9966960" cy="274320"/>
-          </a:xfrm>
-          <a:prstGeom prst="rect">
-            <a:avLst/>
-          </a:prstGeom>
-          <a:noFill/>
-        </p:spPr>
-        <p:txBody>
-          <a:bodyPr wrap="square">
-            <a:spAutoFit/>
-          </a:bodyPr>
-          <a:lstStyle/>
-          <a:p>
-            <a:pPr algn="l">
-              <a:defRPr sz="1100" b="0" i="0">
-                <a:solidFill>
-                  <a:srgbClr val="5C6270"/>
-                </a:solidFill>
-                <a:latin typeface="Calibri"/>
-              </a:defRPr>
-            </a:pPr>
-            <a:r>
-              <a:t>#general</a:t>
+              <a:defRPr sz="1200" b="1" i="0">
+                <a:solidFill>
+                  <a:srgbClr val="10B981"/>
+                </a:solidFill>
+                <a:latin typeface="Calibri"/>
+              </a:defRPr>
+            </a:pPr>
+            <a:r>
+              <a:t>Teamwork · Excellence</a:t>
             </a:r>
           </a:p>
         </p:txBody>
@@ -3626,7 +3628,7 @@
             <a:avLst/>
           </a:prstGeom>
           <a:solidFill>
-            <a:srgbClr val="66BB6A"/>
+            <a:srgbClr val="F59E0B"/>
           </a:solidFill>
           <a:ln>
             <a:noFill/>
@@ -3679,13 +3681,13 @@
             <a:pPr algn="l">
               <a:defRPr sz="1000" b="1">
                 <a:solidFill>
-                  <a:srgbClr val="66BB6A"/>
-                </a:solidFill>
-                <a:latin typeface="Calibri"/>
-              </a:defRPr>
-            </a:pPr>
-            <a:r>
-              <a:t>🌱  EVENT</a:t>
+                  <a:srgbClr val="F59E0B"/>
+                </a:solidFill>
+                <a:latin typeface="Calibri"/>
+              </a:defRPr>
+            </a:pPr>
+            <a:r>
+              <a:t>⚡  CLAPS</a:t>
             </a:r>
           </a:p>
         </p:txBody>
@@ -3715,13 +3717,13 @@
             <a:pPr algn="l">
               <a:defRPr sz="3200" b="1" i="0">
                 <a:solidFill>
-                  <a:srgbClr val="66BB6A"/>
-                </a:solidFill>
-                <a:latin typeface="Calibri"/>
-              </a:defRPr>
-            </a:pPr>
-            <a:r>
-              <a:t>Spring Launch</a:t>
+                  <a:srgbClr val="F59E0B"/>
+                </a:solidFill>
+                <a:latin typeface="Calibri"/>
+              </a:defRPr>
+            </a:pPr>
+            <a:r>
+              <a:t>Engineering Power</a:t>
             </a:r>
           </a:p>
         </p:txBody>
@@ -3735,21 +3737,93 @@
         <p:spPr>
           <a:xfrm>
             <a:off x="1097280" y="2103120"/>
-            <a:ext cx="9966960" cy="548640"/>
-          </a:xfrm>
-          <a:prstGeom prst="rect">
-            <a:avLst/>
-          </a:prstGeom>
-          <a:noFill/>
-        </p:spPr>
-        <p:txBody>
-          <a:bodyPr wrap="square">
-            <a:spAutoFit/>
-          </a:bodyPr>
-          <a:lstStyle/>
-          <a:p>
-            <a:pPr algn="l">
-              <a:defRPr sz="2200" b="1" i="0">
+            <a:ext cx="2743200" cy="548640"/>
+          </a:xfrm>
+          <a:prstGeom prst="rect">
+            <a:avLst/>
+          </a:prstGeom>
+          <a:noFill/>
+        </p:spPr>
+        <p:txBody>
+          <a:bodyPr wrap="square">
+            <a:spAutoFit/>
+          </a:bodyPr>
+          <a:lstStyle/>
+          <a:p>
+            <a:pPr algn="l">
+              <a:defRPr sz="2800" b="1" i="0">
+                <a:solidFill>
+                  <a:srgbClr val="F59E0B"/>
+                </a:solidFill>
+                <a:latin typeface="Calibri"/>
+              </a:defRPr>
+            </a:pPr>
+            <a:r>
+              <a:t>50</a:t>
+            </a:r>
+          </a:p>
+        </p:txBody>
+      </p:sp>
+      <p:sp>
+        <p:nvSpPr>
+          <p:cNvPr id="6" name="TextBox 5"/>
+          <p:cNvSpPr txBox="1"/>
+          <p:nvPr/>
+        </p:nvSpPr>
+        <p:spPr>
+          <a:xfrm>
+            <a:off x="1097280" y="2651760"/>
+            <a:ext cx="9966960" cy="365760"/>
+          </a:xfrm>
+          <a:prstGeom prst="rect">
+            <a:avLst/>
+          </a:prstGeom>
+          <a:noFill/>
+        </p:spPr>
+        <p:txBody>
+          <a:bodyPr wrap="square">
+            <a:spAutoFit/>
+          </a:bodyPr>
+          <a:lstStyle/>
+          <a:p>
+            <a:pPr algn="l">
+              <a:defRPr sz="1400" b="0" i="0">
+                <a:solidFill>
+                  <a:srgbClr val="E2E2EA"/>
+                </a:solidFill>
+                <a:latin typeface="Calibri"/>
+              </a:defRPr>
+            </a:pPr>
+            <a:r>
+              <a:t>from Valentino Agazzi Mandozzi</a:t>
+            </a:r>
+          </a:p>
+        </p:txBody>
+      </p:sp>
+      <p:sp>
+        <p:nvSpPr>
+          <p:cNvPr id="7" name="TextBox 6"/>
+          <p:cNvSpPr txBox="1"/>
+          <p:nvPr/>
+        </p:nvSpPr>
+        <p:spPr>
+          <a:xfrm>
+            <a:off x="1097280" y="3108960"/>
+            <a:ext cx="9966960" cy="365760"/>
+          </a:xfrm>
+          <a:prstGeom prst="rect">
+            <a:avLst/>
+          </a:prstGeom>
+          <a:noFill/>
+        </p:spPr>
+        <p:txBody>
+          <a:bodyPr wrap="square">
+            <a:spAutoFit/>
+          </a:bodyPr>
+          <a:lstStyle/>
+          <a:p>
+            <a:pPr algn="l">
+              <a:defRPr sz="1400" b="1" i="0">
                 <a:solidFill>
                   <a:srgbClr val="FFFFFF"/>
                 </a:solidFill>
@@ -3757,71 +3831,35 @@
               </a:defRPr>
             </a:pPr>
             <a:r>
-              <a:t>Connect Groups Spring Season</a:t>
-            </a:r>
-          </a:p>
-        </p:txBody>
-      </p:sp>
-      <p:sp>
-        <p:nvSpPr>
-          <p:cNvPr id="6" name="TextBox 5"/>
-          <p:cNvSpPr txBox="1"/>
-          <p:nvPr/>
-        </p:nvSpPr>
-        <p:spPr>
-          <a:xfrm>
-            <a:off x="1097280" y="2743200"/>
-            <a:ext cx="9966960" cy="365760"/>
-          </a:xfrm>
-          <a:prstGeom prst="rect">
-            <a:avLst/>
-          </a:prstGeom>
-          <a:noFill/>
-        </p:spPr>
-        <p:txBody>
-          <a:bodyPr wrap="square">
-            <a:spAutoFit/>
-          </a:bodyPr>
-          <a:lstStyle/>
-          <a:p>
-            <a:pPr algn="l">
-              <a:defRPr sz="1400" b="1" i="0">
-                <a:solidFill>
-                  <a:srgbClr val="66BB6A"/>
-                </a:solidFill>
-                <a:latin typeface="Calibri"/>
-              </a:defRPr>
-            </a:pPr>
-            <a:r>
-              <a:t>March–May 2026</a:t>
-            </a:r>
-          </a:p>
-        </p:txBody>
-      </p:sp>
-      <p:sp>
-        <p:nvSpPr>
-          <p:cNvPr id="7" name="TextBox 6"/>
-          <p:cNvSpPr txBox="1"/>
-          <p:nvPr/>
-        </p:nvSpPr>
-        <p:spPr>
-          <a:xfrm>
-            <a:off x="1097280" y="3291840"/>
-            <a:ext cx="9966960" cy="1371600"/>
-          </a:xfrm>
-          <a:prstGeom prst="rect">
-            <a:avLst/>
-          </a:prstGeom>
-          <a:noFill/>
-        </p:spPr>
-        <p:txBody>
-          <a:bodyPr wrap="square">
-            <a:spAutoFit/>
-          </a:bodyPr>
-          <a:lstStyle/>
-          <a:p>
-            <a:pPr algn="l">
-              <a:defRPr sz="1500" b="0" i="0">
+              <a:t>to: Eren Sakarya</a:t>
+            </a:r>
+          </a:p>
+        </p:txBody>
+      </p:sp>
+      <p:sp>
+        <p:nvSpPr>
+          <p:cNvPr id="8" name="TextBox 7"/>
+          <p:cNvSpPr txBox="1"/>
+          <p:nvPr/>
+        </p:nvSpPr>
+        <p:spPr>
+          <a:xfrm>
+            <a:off x="1097280" y="3749039"/>
+            <a:ext cx="9966960" cy="1097280"/>
+          </a:xfrm>
+          <a:prstGeom prst="rect">
+            <a:avLst/>
+          </a:prstGeom>
+          <a:noFill/>
+        </p:spPr>
+        <p:txBody>
+          <a:bodyPr wrap="square">
+            <a:spAutoFit/>
+          </a:bodyPr>
+          <a:lstStyle/>
+          <a:p>
+            <a:pPr algn="l">
+              <a:defRPr sz="1500" b="0" i="1">
                 <a:solidFill>
                   <a:srgbClr val="E2E2EA"/>
                 </a:solidFill>
@@ -3829,43 +3867,43 @@
               </a:defRPr>
             </a:pPr>
             <a:r>
-              <a:t>Employee-led communities on Circle connecting around shared interests, learning, and ideas — from sports and books to leadership and meaningful conversations</a:t>
-            </a:r>
-          </a:p>
-        </p:txBody>
-      </p:sp>
-      <p:sp>
-        <p:nvSpPr>
-          <p:cNvPr id="8" name="TextBox 7"/>
-          <p:cNvSpPr txBox="1"/>
-          <p:nvPr/>
-        </p:nvSpPr>
-        <p:spPr>
-          <a:xfrm>
-            <a:off x="1097280" y="5029200"/>
-            <a:ext cx="9966960" cy="365760"/>
-          </a:xfrm>
-          <a:prstGeom prst="rect">
-            <a:avLst/>
-          </a:prstGeom>
-          <a:noFill/>
-        </p:spPr>
-        <p:txBody>
-          <a:bodyPr wrap="square">
-            <a:spAutoFit/>
-          </a:bodyPr>
-          <a:lstStyle/>
-          <a:p>
-            <a:pPr algn="l">
-              <a:defRPr sz="1300" b="0" i="0">
-                <a:solidFill>
-                  <a:srgbClr val="8F95A3"/>
-                </a:solidFill>
-                <a:latin typeface="Calibri"/>
-              </a:defRPr>
-            </a:pPr>
-            <a:r>
-              <a:t>Organized by Katarzyna Raniszewska</a:t>
+              <a:t>"Brilliant engineering solutions and execution"</a:t>
+            </a:r>
+          </a:p>
+        </p:txBody>
+      </p:sp>
+      <p:sp>
+        <p:nvSpPr>
+          <p:cNvPr id="9" name="TextBox 8"/>
+          <p:cNvSpPr txBox="1"/>
+          <p:nvPr/>
+        </p:nvSpPr>
+        <p:spPr>
+          <a:xfrm>
+            <a:off x="1097280" y="5120640"/>
+            <a:ext cx="9966960" cy="457200"/>
+          </a:xfrm>
+          <a:prstGeom prst="rect">
+            <a:avLst/>
+          </a:prstGeom>
+          <a:noFill/>
+        </p:spPr>
+        <p:txBody>
+          <a:bodyPr wrap="square">
+            <a:spAutoFit/>
+          </a:bodyPr>
+          <a:lstStyle/>
+          <a:p>
+            <a:pPr algn="l">
+              <a:defRPr sz="1200" b="1" i="0">
+                <a:solidFill>
+                  <a:srgbClr val="F59E0B"/>
+                </a:solidFill>
+                <a:latin typeface="Calibri"/>
+              </a:defRPr>
+            </a:pPr>
+            <a:r>
+              <a:t>Innovation · Excellence</a:t>
             </a:r>
           </a:p>
         </p:txBody>
@@ -3911,7 +3949,7 @@
             <a:avLst/>
           </a:prstGeom>
           <a:solidFill>
-            <a:srgbClr val="FFA726"/>
+            <a:srgbClr val="06B6D4"/>
           </a:solidFill>
           <a:ln>
             <a:noFill/>
@@ -3964,7 +4002,7 @@
             <a:pPr algn="l">
               <a:defRPr sz="1000" b="1">
                 <a:solidFill>
-                  <a:srgbClr val="FFA726"/>
+                  <a:srgbClr val="06B6D4"/>
                 </a:solidFill>
                 <a:latin typeface="Calibri"/>
               </a:defRPr>
@@ -4000,13 +4038,13 @@
             <a:pPr algn="l">
               <a:defRPr sz="3200" b="1" i="0">
                 <a:solidFill>
-                  <a:srgbClr val="FFA726"/>
-                </a:solidFill>
-                <a:latin typeface="Calibri"/>
-              </a:defRPr>
-            </a:pPr>
-            <a:r>
-              <a:t>Cross-Team Excellence</a:t>
+                  <a:srgbClr val="06B6D4"/>
+                </a:solidFill>
+                <a:latin typeface="Calibri"/>
+              </a:defRPr>
+            </a:pPr>
+            <a:r>
+              <a:t>Management Excellence</a:t>
             </a:r>
           </a:p>
         </p:txBody>
@@ -4036,7 +4074,7 @@
             <a:pPr algn="l">
               <a:defRPr sz="2800" b="1" i="0">
                 <a:solidFill>
-                  <a:srgbClr val="FFA726"/>
+                  <a:srgbClr val="06B6D4"/>
                 </a:solidFill>
                 <a:latin typeface="Calibri"/>
               </a:defRPr>
@@ -4150,7 +4188,7 @@
               </a:defRPr>
             </a:pPr>
             <a:r>
-              <a:t>"Outstanding cross-functional collaboration and results delivery"</a:t>
+              <a:t>"Outstanding leadership and team management"</a:t>
             </a:r>
           </a:p>
         </p:txBody>
@@ -4180,13 +4218,13 @@
             <a:pPr algn="l">
               <a:defRPr sz="1200" b="1" i="0">
                 <a:solidFill>
-                  <a:srgbClr val="FFA726"/>
-                </a:solidFill>
-                <a:latin typeface="Calibri"/>
-              </a:defRPr>
-            </a:pPr>
-            <a:r>
-              <a:t>Collaboration · Results</a:t>
+                  <a:srgbClr val="06B6D4"/>
+                </a:solidFill>
+                <a:latin typeface="Calibri"/>
+              </a:defRPr>
+            </a:pPr>
+            <a:r>
+              <a:t>Leadership · Excellence</a:t>
             </a:r>
           </a:p>
         </p:txBody>
@@ -4232,7 +4270,7 @@
             <a:avLst/>
           </a:prstGeom>
           <a:solidFill>
-            <a:srgbClr val="8BC34A"/>
+            <a:srgbClr val="EC4899"/>
           </a:solidFill>
           <a:ln>
             <a:noFill/>
@@ -4285,13 +4323,13 @@
             <a:pPr algn="l">
               <a:defRPr sz="1000" b="1">
                 <a:solidFill>
-                  <a:srgbClr val="8BC34A"/>
-                </a:solidFill>
-                <a:latin typeface="Calibri"/>
-              </a:defRPr>
-            </a:pPr>
-            <a:r>
-              <a:t>🎖️  CLAPS</a:t>
+                  <a:srgbClr val="EC4899"/>
+                </a:solidFill>
+                <a:latin typeface="Calibri"/>
+              </a:defRPr>
+            </a:pPr>
+            <a:r>
+              <a:t>💎  CLAPS</a:t>
             </a:r>
           </a:p>
         </p:txBody>
@@ -4321,13 +4359,13 @@
             <a:pPr algn="l">
               <a:defRPr sz="3200" b="1" i="0">
                 <a:solidFill>
-                  <a:srgbClr val="8BC34A"/>
-                </a:solidFill>
-                <a:latin typeface="Calibri"/>
-              </a:defRPr>
-            </a:pPr>
-            <a:r>
-              <a:t>Multi-Team Recognition</a:t>
+                  <a:srgbClr val="EC4899"/>
+                </a:solidFill>
+                <a:latin typeface="Calibri"/>
+              </a:defRPr>
+            </a:pPr>
+            <a:r>
+              <a:t>Quality Delivery</a:t>
             </a:r>
           </a:p>
         </p:txBody>
@@ -4357,13 +4395,13 @@
             <a:pPr algn="l">
               <a:defRPr sz="2800" b="1" i="0">
                 <a:solidFill>
-                  <a:srgbClr val="8BC34A"/>
-                </a:solidFill>
-                <a:latin typeface="Calibri"/>
-              </a:defRPr>
-            </a:pPr>
-            <a:r>
-              <a:t>15</a:t>
+                  <a:srgbClr val="EC4899"/>
+                </a:solidFill>
+                <a:latin typeface="Calibri"/>
+              </a:defRPr>
+            </a:pPr>
+            <a:r>
+              <a:t>25</a:t>
             </a:r>
           </a:p>
         </p:txBody>
@@ -4399,7 +4437,7 @@
               </a:defRPr>
             </a:pPr>
             <a:r>
-              <a:t>from Agustin</a:t>
+              <a:t>from Iurii Kotov</a:t>
             </a:r>
           </a:p>
         </p:txBody>
@@ -4435,7 +4473,7 @@
               </a:defRPr>
             </a:pPr>
             <a:r>
-              <a:t>to: aleksandr.chigaleichik</a:t>
+              <a:t>to: Ana Abuseridze</a:t>
             </a:r>
           </a:p>
         </p:txBody>
@@ -4471,7 +4509,7 @@
               </a:defRPr>
             </a:pPr>
             <a:r>
-              <a:t>"Exceptional problem-solving and technical guidance"</a:t>
+              <a:t>"Exceptional quality and attention to detail"</a:t>
             </a:r>
           </a:p>
         </p:txBody>
@@ -4501,13 +4539,13 @@
             <a:pPr algn="l">
               <a:defRPr sz="1200" b="1" i="0">
                 <a:solidFill>
-                  <a:srgbClr val="8BC34A"/>
-                </a:solidFill>
-                <a:latin typeface="Calibri"/>
-              </a:defRPr>
-            </a:pPr>
-            <a:r>
-              <a:t>Problem Solving · Mentorship</a:t>
+                  <a:srgbClr val="EC4899"/>
+                </a:solidFill>
+                <a:latin typeface="Calibri"/>
+              </a:defRPr>
+            </a:pPr>
+            <a:r>
+              <a:t>Quality · Excellence</a:t>
             </a:r>
           </a:p>
         </p:txBody>
@@ -4553,7 +4591,7 @@
             <a:avLst/>
           </a:prstGeom>
           <a:solidFill>
-            <a:srgbClr val="29B6F6"/>
+            <a:srgbClr val="EF4444"/>
           </a:solidFill>
           <a:ln>
             <a:noFill/>
@@ -4606,13 +4644,13 @@
             <a:pPr algn="l">
               <a:defRPr sz="1000" b="1">
                 <a:solidFill>
-                  <a:srgbClr val="29B6F6"/>
-                </a:solidFill>
-                <a:latin typeface="Calibri"/>
-              </a:defRPr>
-            </a:pPr>
-            <a:r>
-              <a:t>🏆  CLAPS</a:t>
+                  <a:srgbClr val="EF4444"/>
+                </a:solidFill>
+                <a:latin typeface="Calibri"/>
+              </a:defRPr>
+            </a:pPr>
+            <a:r>
+              <a:t>🔥  CLAPS</a:t>
             </a:r>
           </a:p>
         </p:txBody>
@@ -4642,13 +4680,13 @@
             <a:pPr algn="l">
               <a:defRPr sz="3200" b="1" i="0">
                 <a:solidFill>
-                  <a:srgbClr val="29B6F6"/>
-                </a:solidFill>
-                <a:latin typeface="Calibri"/>
-              </a:defRPr>
-            </a:pPr>
-            <a:r>
-              <a:t>Team Collaboration</a:t>
+                  <a:srgbClr val="EF4444"/>
+                </a:solidFill>
+                <a:latin typeface="Calibri"/>
+              </a:defRPr>
+            </a:pPr>
+            <a:r>
+              <a:t>Technical Mastery</a:t>
             </a:r>
           </a:p>
         </p:txBody>
@@ -4678,7 +4716,7 @@
             <a:pPr algn="l">
               <a:defRPr sz="2800" b="1" i="0">
                 <a:solidFill>
-                  <a:srgbClr val="29B6F6"/>
+                  <a:srgbClr val="EF4444"/>
                 </a:solidFill>
                 <a:latin typeface="Calibri"/>
               </a:defRPr>
@@ -4756,7 +4794,7 @@
               </a:defRPr>
             </a:pPr>
             <a:r>
-              <a:t>to: Ana Abuseridze</a:t>
+              <a:t>to: Dima M.</a:t>
             </a:r>
           </a:p>
         </p:txBody>
@@ -4792,7 +4830,7 @@
               </a:defRPr>
             </a:pPr>
             <a:r>
-              <a:t>"Outstanding teamwork and collaborative spirit"</a:t>
+              <a:t>"Outstanding technical expertise and problem-solving"</a:t>
             </a:r>
           </a:p>
         </p:txBody>
@@ -4822,13 +4860,13 @@
             <a:pPr algn="l">
               <a:defRPr sz="1200" b="1" i="0">
                 <a:solidFill>
-                  <a:srgbClr val="29B6F6"/>
-                </a:solidFill>
-                <a:latin typeface="Calibri"/>
-              </a:defRPr>
-            </a:pPr>
-            <a:r>
-              <a:t>Teamwork · Collaboration</a:t>
+                  <a:srgbClr val="EF4444"/>
+                </a:solidFill>
+                <a:latin typeface="Calibri"/>
+              </a:defRPr>
+            </a:pPr>
+            <a:r>
+              <a:t>Technical Excellence · Innovation</a:t>
             </a:r>
           </a:p>
         </p:txBody>
@@ -4874,7 +4912,7 @@
             <a:avLst/>
           </a:prstGeom>
           <a:solidFill>
-            <a:srgbClr val="4CAF50"/>
+            <a:srgbClr val="8B5CF6"/>
           </a:solidFill>
           <a:ln>
             <a:noFill/>
@@ -4927,13 +4965,13 @@
             <a:pPr algn="l">
               <a:defRPr sz="1000" b="1">
                 <a:solidFill>
-                  <a:srgbClr val="4CAF50"/>
-                </a:solidFill>
-                <a:latin typeface="Calibri"/>
-              </a:defRPr>
-            </a:pPr>
-            <a:r>
-              <a:t>💰  MILESTONE</a:t>
+                  <a:srgbClr val="8B5CF6"/>
+                </a:solidFill>
+                <a:latin typeface="Calibri"/>
+              </a:defRPr>
+            </a:pPr>
+            <a:r>
+              <a:t>🤖  OFFICE LIFE</a:t>
             </a:r>
           </a:p>
         </p:txBody>
@@ -4963,13 +5001,13 @@
             <a:pPr algn="l">
               <a:defRPr sz="3200" b="1" i="0">
                 <a:solidFill>
-                  <a:srgbClr val="4CAF50"/>
-                </a:solidFill>
-                <a:latin typeface="Calibri"/>
-              </a:defRPr>
-            </a:pPr>
-            <a:r>
-              <a:t>Company Growth</a:t>
+                  <a:srgbClr val="8B5CF6"/>
+                </a:solidFill>
+                <a:latin typeface="Calibri"/>
+              </a:defRPr>
+            </a:pPr>
+            <a:r>
+              <a:t>Engineering Security First</a:t>
             </a:r>
           </a:p>
         </p:txBody>
@@ -4983,29 +5021,29 @@
         <p:spPr>
           <a:xfrm>
             <a:off x="1097280" y="2103120"/>
-            <a:ext cx="4572000" cy="822960"/>
-          </a:xfrm>
-          <a:prstGeom prst="rect">
-            <a:avLst/>
-          </a:prstGeom>
-          <a:noFill/>
-        </p:spPr>
-        <p:txBody>
-          <a:bodyPr wrap="square">
-            <a:spAutoFit/>
-          </a:bodyPr>
-          <a:lstStyle/>
-          <a:p>
-            <a:pPr algn="l">
-              <a:defRPr sz="5200" b="1" i="0">
-                <a:solidFill>
-                  <a:srgbClr val="4CAF50"/>
-                </a:solidFill>
-                <a:latin typeface="Calibri"/>
-              </a:defRPr>
-            </a:pPr>
-            <a:r>
-              <a:t>40%</a:t>
+            <a:ext cx="9966960" cy="457200"/>
+          </a:xfrm>
+          <a:prstGeom prst="rect">
+            <a:avLst/>
+          </a:prstGeom>
+          <a:noFill/>
+        </p:spPr>
+        <p:txBody>
+          <a:bodyPr wrap="square">
+            <a:spAutoFit/>
+          </a:bodyPr>
+          <a:lstStyle/>
+          <a:p>
+            <a:pPr algn="l">
+              <a:defRPr sz="1800" b="1" i="0">
+                <a:solidFill>
+                  <a:srgbClr val="FFFFFF"/>
+                </a:solidFill>
+                <a:latin typeface="Calibri"/>
+              </a:defRPr>
+            </a:pPr>
+            <a:r>
+              <a:t>Coolify: Power with Responsibility</a:t>
             </a:r>
           </a:p>
         </p:txBody>
@@ -5018,8 +5056,116 @@
         </p:nvSpPr>
         <p:spPr>
           <a:xfrm>
-            <a:off x="1097280" y="2926080"/>
-            <a:ext cx="4572000" cy="365760"/>
+            <a:off x="1371600" y="2743200"/>
+            <a:ext cx="9692640" cy="1828800"/>
+          </a:xfrm>
+          <a:prstGeom prst="rect">
+            <a:avLst/>
+          </a:prstGeom>
+          <a:noFill/>
+        </p:spPr>
+        <p:txBody>
+          <a:bodyPr wrap="square">
+            <a:spAutoFit/>
+          </a:bodyPr>
+          <a:lstStyle/>
+          <a:p>
+            <a:pPr algn="l">
+              <a:defRPr sz="1500" b="0" i="1">
+                <a:solidFill>
+                  <a:srgbClr val="E2E2EA"/>
+                </a:solidFill>
+                <a:latin typeface="Calibri"/>
+              </a:defRPr>
+            </a:pPr>
+            <a:r>
+              <a:t>"Unfortunately, AI doesn't always generate secure applications, so Coolify and all services deployed in it are accessible by everyone in the company"</a:t>
+            </a:r>
+          </a:p>
+        </p:txBody>
+      </p:sp>
+      <p:sp>
+        <p:nvSpPr>
+          <p:cNvPr id="7" name="TextBox 6"/>
+          <p:cNvSpPr txBox="1"/>
+          <p:nvPr/>
+        </p:nvSpPr>
+        <p:spPr>
+          <a:xfrm>
+            <a:off x="1097280" y="4754880"/>
+            <a:ext cx="9966960" cy="365760"/>
+          </a:xfrm>
+          <a:prstGeom prst="rect">
+            <a:avLst/>
+          </a:prstGeom>
+          <a:noFill/>
+        </p:spPr>
+        <p:txBody>
+          <a:bodyPr wrap="square">
+            <a:spAutoFit/>
+          </a:bodyPr>
+          <a:lstStyle/>
+          <a:p>
+            <a:pPr algn="l">
+              <a:defRPr sz="1400" b="0" i="0">
+                <a:solidFill>
+                  <a:srgbClr val="8F95A3"/>
+                </a:solidFill>
+                <a:latin typeface="Calibri"/>
+              </a:defRPr>
+            </a:pPr>
+            <a:r>
+              <a:t>— Gleb Krahotkin</a:t>
+            </a:r>
+          </a:p>
+        </p:txBody>
+      </p:sp>
+      <p:sp>
+        <p:nvSpPr>
+          <p:cNvPr id="8" name="TextBox 7"/>
+          <p:cNvSpPr txBox="1"/>
+          <p:nvPr/>
+        </p:nvSpPr>
+        <p:spPr>
+          <a:xfrm>
+            <a:off x="1097280" y="5212080"/>
+            <a:ext cx="9966960" cy="365760"/>
+          </a:xfrm>
+          <a:prstGeom prst="rect">
+            <a:avLst/>
+          </a:prstGeom>
+          <a:noFill/>
+        </p:spPr>
+        <p:txBody>
+          <a:bodyPr wrap="square">
+            <a:spAutoFit/>
+          </a:bodyPr>
+          <a:lstStyle/>
+          <a:p>
+            <a:pPr algn="l">
+              <a:defRPr sz="1400" b="1" i="0">
+                <a:solidFill>
+                  <a:srgbClr val="8B5CF6"/>
+                </a:solidFill>
+                <a:latin typeface="Calibri"/>
+              </a:defRPr>
+            </a:pPr>
+            <a:r>
+              <a:t>🔒 ⚠️ 🛡️</a:t>
+            </a:r>
+          </a:p>
+        </p:txBody>
+      </p:sp>
+      <p:sp>
+        <p:nvSpPr>
+          <p:cNvPr id="9" name="TextBox 8"/>
+          <p:cNvSpPr txBox="1"/>
+          <p:nvPr/>
+        </p:nvSpPr>
+        <p:spPr>
+          <a:xfrm>
+            <a:off x="1097280" y="5760720"/>
+            <a:ext cx="9966960" cy="274320"/>
           </a:xfrm>
           <a:prstGeom prst="rect">
             <a:avLst/>
@@ -5035,85 +5181,13 @@
             <a:pPr algn="l">
               <a:defRPr sz="1100" b="0" i="0">
                 <a:solidFill>
-                  <a:srgbClr val="8F95A3"/>
-                </a:solidFill>
-                <a:latin typeface="Calibri"/>
-              </a:defRPr>
-            </a:pPr>
-            <a:r>
-              <a:t>YoY Growth</a:t>
-            </a:r>
-          </a:p>
-        </p:txBody>
-      </p:sp>
-      <p:sp>
-        <p:nvSpPr>
-          <p:cNvPr id="7" name="TextBox 6"/>
-          <p:cNvSpPr txBox="1"/>
-          <p:nvPr/>
-        </p:nvSpPr>
-        <p:spPr>
-          <a:xfrm>
-            <a:off x="1097280" y="3566160"/>
-            <a:ext cx="9966960" cy="457200"/>
-          </a:xfrm>
-          <a:prstGeom prst="rect">
-            <a:avLst/>
-          </a:prstGeom>
-          <a:noFill/>
-        </p:spPr>
-        <p:txBody>
-          <a:bodyPr wrap="square">
-            <a:spAutoFit/>
-          </a:bodyPr>
-          <a:lstStyle/>
-          <a:p>
-            <a:pPr algn="l">
-              <a:defRPr sz="1800" b="1" i="0">
-                <a:solidFill>
-                  <a:srgbClr val="FFFFFF"/>
-                </a:solidFill>
-                <a:latin typeface="Calibri"/>
-              </a:defRPr>
-            </a:pPr>
-            <a:r>
-              <a:t>Record Financial Performance</a:t>
-            </a:r>
-          </a:p>
-        </p:txBody>
-      </p:sp>
-      <p:sp>
-        <p:nvSpPr>
-          <p:cNvPr id="8" name="TextBox 7"/>
-          <p:cNvSpPr txBox="1"/>
-          <p:nvPr/>
-        </p:nvSpPr>
-        <p:spPr>
-          <a:xfrm>
-            <a:off x="1097280" y="4206240"/>
-            <a:ext cx="9966960" cy="1371600"/>
-          </a:xfrm>
-          <a:prstGeom prst="rect">
-            <a:avLst/>
-          </a:prstGeom>
-          <a:noFill/>
-        </p:spPr>
-        <p:txBody>
-          <a:bodyPr wrap="square">
-            <a:spAutoFit/>
-          </a:bodyPr>
-          <a:lstStyle/>
-          <a:p>
-            <a:pPr algn="l">
-              <a:defRPr sz="1500" b="0" i="0">
-                <a:solidFill>
-                  <a:srgbClr val="E2E2EA"/>
-                </a:solidFill>
-                <a:latin typeface="Calibri"/>
-              </a:defRPr>
-            </a:pPr>
-            <a:r>
-              <a:t>Approaching $100M gross profit with $20M EBITDA, maintaining strong 40% year-over-year growth trajectory</a:t>
+                  <a:srgbClr val="5C6270"/>
+                </a:solidFill>
+                <a:latin typeface="Calibri"/>
+              </a:defRPr>
+            </a:pPr>
+            <a:r>
+              <a:t>#general</a:t>
             </a:r>
           </a:p>
         </p:txBody>
@@ -5159,7 +5233,7 @@
             <a:avLst/>
           </a:prstGeom>
           <a:solidFill>
-            <a:srgbClr val="E91E63"/>
+            <a:srgbClr val="10B981"/>
           </a:solidFill>
           <a:ln>
             <a:noFill/>
@@ -5212,13 +5286,13 @@
             <a:pPr algn="l">
               <a:defRPr sz="1000" b="1">
                 <a:solidFill>
-                  <a:srgbClr val="E91E63"/>
-                </a:solidFill>
-                <a:latin typeface="Calibri"/>
-              </a:defRPr>
-            </a:pPr>
-            <a:r>
-              <a:t>🎮  MILESTONE</a:t>
+                  <a:srgbClr val="10B981"/>
+                </a:solidFill>
+                <a:latin typeface="Calibri"/>
+              </a:defRPr>
+            </a:pPr>
+            <a:r>
+              <a:t>💰  MILESTONE</a:t>
             </a:r>
           </a:p>
         </p:txBody>
@@ -5248,13 +5322,13 @@
             <a:pPr algn="l">
               <a:defRPr sz="3200" b="1" i="0">
                 <a:solidFill>
-                  <a:srgbClr val="E91E63"/>
-                </a:solidFill>
-                <a:latin typeface="Calibri"/>
-              </a:defRPr>
-            </a:pPr>
-            <a:r>
-              <a:t>Gaming Success</a:t>
+                  <a:srgbClr val="10B981"/>
+                </a:solidFill>
+                <a:latin typeface="Calibri"/>
+              </a:defRPr>
+            </a:pPr>
+            <a:r>
+              <a:t>Revenue Powerhouse</a:t>
             </a:r>
           </a:p>
         </p:txBody>
@@ -5284,13 +5358,13 @@
             <a:pPr algn="l">
               <a:defRPr sz="5200" b="1" i="0">
                 <a:solidFill>
-                  <a:srgbClr val="E91E63"/>
-                </a:solidFill>
-                <a:latin typeface="Calibri"/>
-              </a:defRPr>
-            </a:pPr>
-            <a:r>
-              <a:t>200%</a:t>
+                  <a:srgbClr val="10B981"/>
+                </a:solidFill>
+                <a:latin typeface="Calibri"/>
+              </a:defRPr>
+            </a:pPr>
+            <a:r>
+              <a:t>$100M</a:t>
             </a:r>
           </a:p>
         </p:txBody>
@@ -5326,7 +5400,7 @@
               </a:defRPr>
             </a:pPr>
             <a:r>
-              <a:t>ROAS Milestone</a:t>
+              <a:t>gross profit achieved</a:t>
             </a:r>
           </a:p>
         </p:txBody>
@@ -5362,7 +5436,7 @@
               </a:defRPr>
             </a:pPr>
             <a:r>
-              <a:t>Gaming Division Turns Profitable</a:t>
+              <a:t>$100M Gross Profit Milestone</a:t>
             </a:r>
           </a:p>
         </p:txBody>
@@ -5398,7 +5472,7 @@
               </a:defRPr>
             </a:pPr>
             <a:r>
-              <a:t>Infinite Minesweeper hits 61% retention rate, Solitaire v540 achieves +21.67% D7 retention boost, and Crossword exceeds 200% ROAS</a:t>
+              <a:t>We've reached approximately $100M in gross profit with $20M EBITDA and 40% year-over-year growth projected. Our financial engine is firing on all cylinders.</a:t>
             </a:r>
           </a:p>
         </p:txBody>
@@ -5444,7 +5518,7 @@
             <a:avLst/>
           </a:prstGeom>
           <a:solidFill>
-            <a:srgbClr val="FF5722"/>
+            <a:srgbClr val="F59E0B"/>
           </a:solidFill>
           <a:ln>
             <a:noFill/>
@@ -5497,13 +5571,13 @@
             <a:pPr algn="l">
               <a:defRPr sz="1000" b="1">
                 <a:solidFill>
-                  <a:srgbClr val="FF5722"/>
-                </a:solidFill>
-                <a:latin typeface="Calibri"/>
-              </a:defRPr>
-            </a:pPr>
-            <a:r>
-              <a:t>🛡️  MILESTONE</a:t>
+                  <a:srgbClr val="F59E0B"/>
+                </a:solidFill>
+                <a:latin typeface="Calibri"/>
+              </a:defRPr>
+            </a:pPr>
+            <a:r>
+              <a:t>🎯  MILESTONE</a:t>
             </a:r>
           </a:p>
         </p:txBody>
@@ -5533,13 +5607,13 @@
             <a:pPr algn="l">
               <a:defRPr sz="3200" b="1" i="0">
                 <a:solidFill>
-                  <a:srgbClr val="FF5722"/>
-                </a:solidFill>
-                <a:latin typeface="Calibri"/>
-              </a:defRPr>
-            </a:pPr>
-            <a:r>
-              <a:t>Security Victory</a:t>
+                  <a:srgbClr val="F59E0B"/>
+                </a:solidFill>
+                <a:latin typeface="Calibri"/>
+              </a:defRPr>
+            </a:pPr>
+            <a:r>
+              <a:t>AI-Powered Workforce</a:t>
             </a:r>
           </a:p>
         </p:txBody>
@@ -5569,13 +5643,13 @@
             <a:pPr algn="l">
               <a:defRPr sz="5200" b="1" i="0">
                 <a:solidFill>
-                  <a:srgbClr val="FF5722"/>
-                </a:solidFill>
-                <a:latin typeface="Calibri"/>
-              </a:defRPr>
-            </a:pPr>
-            <a:r>
-              <a:t>82%</a:t>
+                  <a:srgbClr val="F59E0B"/>
+                </a:solidFill>
+                <a:latin typeface="Calibri"/>
+              </a:defRPr>
+            </a:pPr>
+            <a:r>
+              <a:t>1,500</a:t>
             </a:r>
           </a:p>
         </p:txBody>
@@ -5611,7 +5685,7 @@
               </a:defRPr>
             </a:pPr>
             <a:r>
-              <a:t>Fraud Reduction</a:t>
+              <a:t>employees × 10 AI agents</a:t>
             </a:r>
           </a:p>
         </p:txBody>
@@ -5647,7 +5721,7 @@
               </a:defRPr>
             </a:pPr>
             <a:r>
-              <a:t>Fraud Rate Dramatically Reduced</a:t>
+              <a:t>Every Employee + 5-10 AI Agents</a:t>
             </a:r>
           </a:p>
         </p:txBody>
@@ -5683,7 +5757,7 @@
               </a:defRPr>
             </a:pPr>
             <a:r>
-              <a:t>Dynamic SDK signatures successfully reduced fraud from 22% to under 4%, protecting revenue and user experience</a:t>
+              <a:t>Within 3-6 months, every Appodeal employee will manage 5-10 AI agents. We're not just using AI — we're becoming an AI-amplified organization where humans and machines work together seamlessly.</a:t>
             </a:r>
           </a:p>
         </p:txBody>
@@ -5729,7 +5803,7 @@
             <a:avLst/>
           </a:prstGeom>
           <a:solidFill>
-            <a:srgbClr val="9C27B0"/>
+            <a:srgbClr val="EC4899"/>
           </a:solidFill>
           <a:ln>
             <a:noFill/>
@@ -5782,13 +5856,13 @@
             <a:pPr algn="l">
               <a:defRPr sz="1000" b="1">
                 <a:solidFill>
-                  <a:srgbClr val="9C27B0"/>
-                </a:solidFill>
-                <a:latin typeface="Calibri"/>
-              </a:defRPr>
-            </a:pPr>
-            <a:r>
-              <a:t>🤖  MILESTONE</a:t>
+                  <a:srgbClr val="EC4899"/>
+                </a:solidFill>
+                <a:latin typeface="Calibri"/>
+              </a:defRPr>
+            </a:pPr>
+            <a:r>
+              <a:t>🎮  WIN</a:t>
             </a:r>
           </a:p>
         </p:txBody>
@@ -5818,13 +5892,13 @@
             <a:pPr algn="l">
               <a:defRPr sz="3200" b="1" i="0">
                 <a:solidFill>
-                  <a:srgbClr val="9C27B0"/>
-                </a:solidFill>
-                <a:latin typeface="Calibri"/>
-              </a:defRPr>
-            </a:pPr>
-            <a:r>
-              <a:t>AI Transformation</a:t>
+                  <a:srgbClr val="EC4899"/>
+                </a:solidFill>
+                <a:latin typeface="Calibri"/>
+              </a:defRPr>
+            </a:pPr>
+            <a:r>
+              <a:t>Gaming Goes Green</a:t>
             </a:r>
           </a:p>
         </p:txBody>
@@ -5852,15 +5926,15 @@
           <a:lstStyle/>
           <a:p>
             <a:pPr algn="l">
-              <a:defRPr sz="5200" b="1" i="0">
-                <a:solidFill>
-                  <a:srgbClr val="9C27B0"/>
-                </a:solidFill>
-                <a:latin typeface="Calibri"/>
-              </a:defRPr>
-            </a:pPr>
-            <a:r>
-              <a:t>1000+</a:t>
+              <a:defRPr sz="4800" b="1" i="0">
+                <a:solidFill>
+                  <a:srgbClr val="EC4899"/>
+                </a:solidFill>
+                <a:latin typeface="Calibri"/>
+              </a:defRPr>
+            </a:pPr>
+            <a:r>
+              <a:t>100%</a:t>
             </a:r>
           </a:p>
         </p:txBody>
@@ -5873,7 +5947,7 @@
         </p:nvSpPr>
         <p:spPr>
           <a:xfrm>
-            <a:off x="1097280" y="2926080"/>
+            <a:off x="1097280" y="2834640"/>
             <a:ext cx="4572000" cy="365760"/>
           </a:xfrm>
           <a:prstGeom prst="rect">
@@ -5888,7 +5962,7 @@
           <a:lstStyle/>
           <a:p>
             <a:pPr algn="l">
-              <a:defRPr sz="1100" b="0" i="0">
+              <a:defRPr sz="1200" b="0" i="0">
                 <a:solidFill>
                   <a:srgbClr val="8F95A3"/>
                 </a:solidFill>
@@ -5896,7 +5970,7 @@
               </a:defRPr>
             </a:pPr>
             <a:r>
-              <a:t>Daily AI Checks</a:t>
+              <a:t>profitable</a:t>
             </a:r>
           </a:p>
         </p:txBody>
@@ -5909,7 +5983,43 @@
         </p:nvSpPr>
         <p:spPr>
           <a:xfrm>
-            <a:off x="1097280" y="3566160"/>
+            <a:off x="1097280" y="3291840"/>
+            <a:ext cx="9966960" cy="365760"/>
+          </a:xfrm>
+          <a:prstGeom prst="rect">
+            <a:avLst/>
+          </a:prstGeom>
+          <a:noFill/>
+        </p:spPr>
+        <p:txBody>
+          <a:bodyPr wrap="square">
+            <a:spAutoFit/>
+          </a:bodyPr>
+          <a:lstStyle/>
+          <a:p>
+            <a:pPr algn="l">
+              <a:defRPr sz="1400" b="0" i="0">
+                <a:solidFill>
+                  <a:srgbClr val="E2E2EA"/>
+                </a:solidFill>
+                <a:latin typeface="Calibri"/>
+              </a:defRPr>
+            </a:pPr>
+            <a:r>
+              <a:t>by Gaming Division</a:t>
+            </a:r>
+          </a:p>
+        </p:txBody>
+      </p:sp>
+      <p:sp>
+        <p:nvSpPr>
+          <p:cNvPr id="8" name="TextBox 7"/>
+          <p:cNvSpPr txBox="1"/>
+          <p:nvPr/>
+        </p:nvSpPr>
+        <p:spPr>
+          <a:xfrm>
+            <a:off x="1097280" y="3840480"/>
             <a:ext cx="9966960" cy="457200"/>
           </a:xfrm>
           <a:prstGeom prst="rect">
@@ -5932,7 +6042,328 @@
               </a:defRPr>
             </a:pPr>
             <a:r>
-              <a:t>AI-First Future Accelerating</a:t>
+              <a:t>Gaming Division Hits Profitability</a:t>
+            </a:r>
+          </a:p>
+        </p:txBody>
+      </p:sp>
+      <p:sp>
+        <p:nvSpPr>
+          <p:cNvPr id="9" name="TextBox 8"/>
+          <p:cNvSpPr txBox="1"/>
+          <p:nvPr/>
+        </p:nvSpPr>
+        <p:spPr>
+          <a:xfrm>
+            <a:off x="1097280" y="4389120"/>
+            <a:ext cx="9966960" cy="914400"/>
+          </a:xfrm>
+          <a:prstGeom prst="rect">
+            <a:avLst/>
+          </a:prstGeom>
+          <a:noFill/>
+        </p:spPr>
+        <p:txBody>
+          <a:bodyPr wrap="square">
+            <a:spAutoFit/>
+          </a:bodyPr>
+          <a:lstStyle/>
+          <a:p>
+            <a:pPr algn="l">
+              <a:defRPr sz="1400" b="0" i="0">
+                <a:solidFill>
+                  <a:srgbClr val="E2E2EA"/>
+                </a:solidFill>
+                <a:latin typeface="Calibri"/>
+              </a:defRPr>
+            </a:pPr>
+            <a:r>
+              <a:t>After years of investment and optimization, our gaming division finally turned profitable in 2025. A testament to persistence and strategic execution.</a:t>
+            </a:r>
+          </a:p>
+        </p:txBody>
+      </p:sp>
+      <p:sp>
+        <p:nvSpPr>
+          <p:cNvPr id="10" name="TextBox 9"/>
+          <p:cNvSpPr txBox="1"/>
+          <p:nvPr/>
+        </p:nvSpPr>
+        <p:spPr>
+          <a:xfrm>
+            <a:off x="1097280" y="5486400"/>
+            <a:ext cx="9966960" cy="457200"/>
+          </a:xfrm>
+          <a:prstGeom prst="rect">
+            <a:avLst/>
+          </a:prstGeom>
+          <a:noFill/>
+        </p:spPr>
+        <p:txBody>
+          <a:bodyPr wrap="square">
+            <a:spAutoFit/>
+          </a:bodyPr>
+          <a:lstStyle/>
+          <a:p>
+            <a:pPr algn="l">
+              <a:defRPr sz="1300" b="0" i="1">
+                <a:solidFill>
+                  <a:srgbClr val="8F95A3"/>
+                </a:solidFill>
+                <a:latin typeface="Calibri"/>
+              </a:defRPr>
+            </a:pPr>
+            <a:r>
+              <a:t>💬 "Long-term vision pays off"</a:t>
+            </a:r>
+          </a:p>
+        </p:txBody>
+      </p:sp>
+    </p:spTree>
+  </p:cSld>
+  <p:clrMapOvr>
+    <a:masterClrMapping/>
+  </p:clrMapOvr>
+</p:sld>
+</file>
+
+<file path=ppt/slides/slide19.xml><?xml version="1.0" encoding="utf-8"?>
+<p:sld xmlns:a="http://schemas.openxmlformats.org/drawingml/2006/main" xmlns:p="http://schemas.openxmlformats.org/presentationml/2006/main" xmlns:r="http://schemas.openxmlformats.org/officeDocument/2006/relationships">
+  <p:cSld>
+    <p:bg>
+      <p:bgPr>
+        <a:solidFill>
+          <a:srgbClr val="08080C"/>
+        </a:solidFill>
+        <a:effectLst/>
+      </p:bgPr>
+    </p:bg>
+    <p:spTree>
+      <p:nvGrpSpPr>
+        <p:cNvPr id="1" name=""/>
+        <p:cNvGrpSpPr/>
+        <p:nvPr/>
+      </p:nvGrpSpPr>
+      <p:grpSpPr/>
+      <p:sp>
+        <p:nvSpPr>
+          <p:cNvPr id="2" name="Rectangle 1"/>
+          <p:cNvSpPr/>
+          <p:nvPr/>
+        </p:nvSpPr>
+        <p:spPr>
+          <a:xfrm>
+            <a:off x="0" y="365760"/>
+            <a:ext cx="12191695" cy="54864"/>
+          </a:xfrm>
+          <a:prstGeom prst="rect">
+            <a:avLst/>
+          </a:prstGeom>
+          <a:solidFill>
+            <a:srgbClr val="06B6D4"/>
+          </a:solidFill>
+          <a:ln>
+            <a:noFill/>
+          </a:ln>
+        </p:spPr>
+        <p:style>
+          <a:lnRef idx="1">
+            <a:schemeClr val="accent1"/>
+          </a:lnRef>
+          <a:fillRef idx="3">
+            <a:schemeClr val="accent1"/>
+          </a:fillRef>
+          <a:effectRef idx="2">
+            <a:schemeClr val="accent1"/>
+          </a:effectRef>
+          <a:fontRef idx="minor">
+            <a:schemeClr val="lt1"/>
+          </a:fontRef>
+        </p:style>
+        <p:txBody>
+          <a:bodyPr rtlCol="0" anchor="ctr"/>
+          <a:lstStyle/>
+          <a:p>
+            <a:pPr algn="ctr"/>
+          </a:p>
+        </p:txBody>
+      </p:sp>
+      <p:sp>
+        <p:nvSpPr>
+          <p:cNvPr id="3" name="TextBox 2"/>
+          <p:cNvSpPr txBox="1"/>
+          <p:nvPr/>
+        </p:nvSpPr>
+        <p:spPr>
+          <a:xfrm>
+            <a:off x="1097280" y="731520"/>
+            <a:ext cx="3657600" cy="365760"/>
+          </a:xfrm>
+          <a:prstGeom prst="rect">
+            <a:avLst/>
+          </a:prstGeom>
+          <a:noFill/>
+        </p:spPr>
+        <p:txBody>
+          <a:bodyPr wrap="none">
+            <a:spAutoFit/>
+          </a:bodyPr>
+          <a:lstStyle/>
+          <a:p>
+            <a:pPr algn="l">
+              <a:defRPr sz="1000" b="1">
+                <a:solidFill>
+                  <a:srgbClr val="06B6D4"/>
+                </a:solidFill>
+                <a:latin typeface="Calibri"/>
+              </a:defRPr>
+            </a:pPr>
+            <a:r>
+              <a:t>💎  WIN</a:t>
+            </a:r>
+          </a:p>
+        </p:txBody>
+      </p:sp>
+      <p:sp>
+        <p:nvSpPr>
+          <p:cNvPr id="4" name="TextBox 3"/>
+          <p:cNvSpPr txBox="1"/>
+          <p:nvPr/>
+        </p:nvSpPr>
+        <p:spPr>
+          <a:xfrm>
+            <a:off x="1097280" y="1188720"/>
+            <a:ext cx="9966960" cy="731520"/>
+          </a:xfrm>
+          <a:prstGeom prst="rect">
+            <a:avLst/>
+          </a:prstGeom>
+          <a:noFill/>
+        </p:spPr>
+        <p:txBody>
+          <a:bodyPr wrap="square">
+            <a:spAutoFit/>
+          </a:bodyPr>
+          <a:lstStyle/>
+          <a:p>
+            <a:pPr algn="l">
+              <a:defRPr sz="3200" b="1" i="0">
+                <a:solidFill>
+                  <a:srgbClr val="06B6D4"/>
+                </a:solidFill>
+                <a:latin typeface="Calibri"/>
+              </a:defRPr>
+            </a:pPr>
+            <a:r>
+              <a:t>Retention Champion</a:t>
+            </a:r>
+          </a:p>
+        </p:txBody>
+      </p:sp>
+      <p:sp>
+        <p:nvSpPr>
+          <p:cNvPr id="5" name="TextBox 4"/>
+          <p:cNvSpPr txBox="1"/>
+          <p:nvPr/>
+        </p:nvSpPr>
+        <p:spPr>
+          <a:xfrm>
+            <a:off x="1097280" y="2103120"/>
+            <a:ext cx="4572000" cy="822960"/>
+          </a:xfrm>
+          <a:prstGeom prst="rect">
+            <a:avLst/>
+          </a:prstGeom>
+          <a:noFill/>
+        </p:spPr>
+        <p:txBody>
+          <a:bodyPr wrap="square">
+            <a:spAutoFit/>
+          </a:bodyPr>
+          <a:lstStyle/>
+          <a:p>
+            <a:pPr algn="l">
+              <a:defRPr sz="4800" b="1" i="0">
+                <a:solidFill>
+                  <a:srgbClr val="06B6D4"/>
+                </a:solidFill>
+                <a:latin typeface="Calibri"/>
+              </a:defRPr>
+            </a:pPr>
+            <a:r>
+              <a:t>61%</a:t>
+            </a:r>
+          </a:p>
+        </p:txBody>
+      </p:sp>
+      <p:sp>
+        <p:nvSpPr>
+          <p:cNvPr id="6" name="TextBox 5"/>
+          <p:cNvSpPr txBox="1"/>
+          <p:nvPr/>
+        </p:nvSpPr>
+        <p:spPr>
+          <a:xfrm>
+            <a:off x="1097280" y="2834640"/>
+            <a:ext cx="4572000" cy="365760"/>
+          </a:xfrm>
+          <a:prstGeom prst="rect">
+            <a:avLst/>
+          </a:prstGeom>
+          <a:noFill/>
+        </p:spPr>
+        <p:txBody>
+          <a:bodyPr wrap="square">
+            <a:spAutoFit/>
+          </a:bodyPr>
+          <a:lstStyle/>
+          <a:p>
+            <a:pPr algn="l">
+              <a:defRPr sz="1200" b="0" i="0">
+                <a:solidFill>
+                  <a:srgbClr val="8F95A3"/>
+                </a:solidFill>
+                <a:latin typeface="Calibri"/>
+              </a:defRPr>
+            </a:pPr>
+            <a:r>
+              <a:t>retention</a:t>
+            </a:r>
+          </a:p>
+        </p:txBody>
+      </p:sp>
+      <p:sp>
+        <p:nvSpPr>
+          <p:cNvPr id="7" name="TextBox 6"/>
+          <p:cNvSpPr txBox="1"/>
+          <p:nvPr/>
+        </p:nvSpPr>
+        <p:spPr>
+          <a:xfrm>
+            <a:off x="1097280" y="3291840"/>
+            <a:ext cx="9966960" cy="365760"/>
+          </a:xfrm>
+          <a:prstGeom prst="rect">
+            <a:avLst/>
+          </a:prstGeom>
+          <a:noFill/>
+        </p:spPr>
+        <p:txBody>
+          <a:bodyPr wrap="square">
+            <a:spAutoFit/>
+          </a:bodyPr>
+          <a:lstStyle/>
+          <a:p>
+            <a:pPr algn="l">
+              <a:defRPr sz="1400" b="0" i="0">
+                <a:solidFill>
+                  <a:srgbClr val="E2E2EA"/>
+                </a:solidFill>
+                <a:latin typeface="Calibri"/>
+              </a:defRPr>
+            </a:pPr>
+            <a:r>
+              <a:t>by Infinite Minesweeper Team</a:t>
             </a:r>
           </a:p>
         </p:txBody>
@@ -5945,22 +6376,58 @@
         </p:nvSpPr>
         <p:spPr>
           <a:xfrm>
-            <a:off x="1097280" y="4206240"/>
-            <a:ext cx="9966960" cy="1371600"/>
-          </a:xfrm>
-          <a:prstGeom prst="rect">
-            <a:avLst/>
-          </a:prstGeom>
-          <a:noFill/>
-        </p:spPr>
-        <p:txBody>
-          <a:bodyPr wrap="square">
-            <a:spAutoFit/>
-          </a:bodyPr>
-          <a:lstStyle/>
-          <a:p>
-            <a:pPr algn="l">
-              <a:defRPr sz="1500" b="0" i="0">
+            <a:off x="1097280" y="3840480"/>
+            <a:ext cx="9966960" cy="457200"/>
+          </a:xfrm>
+          <a:prstGeom prst="rect">
+            <a:avLst/>
+          </a:prstGeom>
+          <a:noFill/>
+        </p:spPr>
+        <p:txBody>
+          <a:bodyPr wrap="square">
+            <a:spAutoFit/>
+          </a:bodyPr>
+          <a:lstStyle/>
+          <a:p>
+            <a:pPr algn="l">
+              <a:defRPr sz="1800" b="1" i="0">
+                <a:solidFill>
+                  <a:srgbClr val="FFFFFF"/>
+                </a:solidFill>
+                <a:latin typeface="Calibri"/>
+              </a:defRPr>
+            </a:pPr>
+            <a:r>
+              <a:t>Crushing Apple Benchmarks</a:t>
+            </a:r>
+          </a:p>
+        </p:txBody>
+      </p:sp>
+      <p:sp>
+        <p:nvSpPr>
+          <p:cNvPr id="9" name="TextBox 8"/>
+          <p:cNvSpPr txBox="1"/>
+          <p:nvPr/>
+        </p:nvSpPr>
+        <p:spPr>
+          <a:xfrm>
+            <a:off x="1097280" y="4389120"/>
+            <a:ext cx="9966960" cy="914400"/>
+          </a:xfrm>
+          <a:prstGeom prst="rect">
+            <a:avLst/>
+          </a:prstGeom>
+          <a:noFill/>
+        </p:spPr>
+        <p:txBody>
+          <a:bodyPr wrap="square">
+            <a:spAutoFit/>
+          </a:bodyPr>
+          <a:lstStyle/>
+          <a:p>
+            <a:pPr algn="l">
+              <a:defRPr sz="1400" b="0" i="0">
                 <a:solidFill>
                   <a:srgbClr val="E2E2EA"/>
                 </a:solidFill>
@@ -5968,7 +6435,43 @@
               </a:defRPr>
             </a:pPr>
             <a:r>
-              <a:t>Every employee will manage 5-10 AI agents within 3-6 months. OKR Auditor already checks 1,000+ OKRs daily, Daria AI saves $4k/week</a:t>
+              <a:t>Infinite Minesweeper achieved 61% retention, significantly outperforming Apple's benchmark ERA of 151-160%. Our gaming products are not just profitable — they're sticky.</a:t>
+            </a:r>
+          </a:p>
+        </p:txBody>
+      </p:sp>
+      <p:sp>
+        <p:nvSpPr>
+          <p:cNvPr id="10" name="TextBox 9"/>
+          <p:cNvSpPr txBox="1"/>
+          <p:nvPr/>
+        </p:nvSpPr>
+        <p:spPr>
+          <a:xfrm>
+            <a:off x="1097280" y="5486400"/>
+            <a:ext cx="9966960" cy="457200"/>
+          </a:xfrm>
+          <a:prstGeom prst="rect">
+            <a:avLst/>
+          </a:prstGeom>
+          <a:noFill/>
+        </p:spPr>
+        <p:txBody>
+          <a:bodyPr wrap="square">
+            <a:spAutoFit/>
+          </a:bodyPr>
+          <a:lstStyle/>
+          <a:p>
+            <a:pPr algn="l">
+              <a:defRPr sz="1300" b="0" i="1">
+                <a:solidFill>
+                  <a:srgbClr val="8F95A3"/>
+                </a:solidFill>
+                <a:latin typeface="Calibri"/>
+              </a:defRPr>
+            </a:pPr>
+            <a:r>
+              <a:t>💬 "Quality games = loyal players"</a:t>
             </a:r>
           </a:p>
         </p:txBody>
@@ -6014,7 +6517,7 @@
             <a:avLst/>
           </a:prstGeom>
           <a:solidFill>
-            <a:srgbClr val="FF6B9D"/>
+            <a:srgbClr val="FF6B35"/>
           </a:solidFill>
           <a:ln>
             <a:noFill/>
@@ -6067,13 +6570,13 @@
             <a:pPr algn="l">
               <a:defRPr sz="1000" b="1">
                 <a:solidFill>
-                  <a:srgbClr val="FF6B9D"/>
-                </a:solidFill>
-                <a:latin typeface="Calibri"/>
-              </a:defRPr>
-            </a:pPr>
-            <a:r>
-              <a:t>🎂  CELEBRATION</a:t>
+                  <a:srgbClr val="FF6B35"/>
+                </a:solidFill>
+                <a:latin typeface="Calibri"/>
+              </a:defRPr>
+            </a:pPr>
+            <a:r>
+              <a:t>🚀  WIN</a:t>
             </a:r>
           </a:p>
         </p:txBody>
@@ -6103,13 +6606,13 @@
             <a:pPr algn="l">
               <a:defRPr sz="3200" b="1" i="0">
                 <a:solidFill>
-                  <a:srgbClr val="FF6B9D"/>
-                </a:solidFill>
-                <a:latin typeface="Calibri"/>
-              </a:defRPr>
-            </a:pPr>
-            <a:r>
-              <a:t>Happy Birthday!</a:t>
+                  <a:srgbClr val="FF6B35"/>
+                </a:solidFill>
+                <a:latin typeface="Calibri"/>
+              </a:defRPr>
+            </a:pPr>
+            <a:r>
+              <a:t>Innovation Explosion</a:t>
             </a:r>
           </a:p>
         </p:txBody>
@@ -6123,21 +6626,129 @@
         <p:spPr>
           <a:xfrm>
             <a:off x="1097280" y="2103120"/>
-            <a:ext cx="9966960" cy="640080"/>
-          </a:xfrm>
-          <a:prstGeom prst="rect">
-            <a:avLst/>
-          </a:prstGeom>
-          <a:noFill/>
-        </p:spPr>
-        <p:txBody>
-          <a:bodyPr wrap="square">
-            <a:spAutoFit/>
-          </a:bodyPr>
-          <a:lstStyle/>
-          <a:p>
-            <a:pPr algn="l">
-              <a:defRPr sz="2800" b="1" i="0">
+            <a:ext cx="4572000" cy="822960"/>
+          </a:xfrm>
+          <a:prstGeom prst="rect">
+            <a:avLst/>
+          </a:prstGeom>
+          <a:noFill/>
+        </p:spPr>
+        <p:txBody>
+          <a:bodyPr wrap="square">
+            <a:spAutoFit/>
+          </a:bodyPr>
+          <a:lstStyle/>
+          <a:p>
+            <a:pPr algn="l">
+              <a:defRPr sz="4800" b="1" i="0">
+                <a:solidFill>
+                  <a:srgbClr val="FF6B35"/>
+                </a:solidFill>
+                <a:latin typeface="Calibri"/>
+              </a:defRPr>
+            </a:pPr>
+            <a:r>
+              <a:t>100+</a:t>
+            </a:r>
+          </a:p>
+        </p:txBody>
+      </p:sp>
+      <p:sp>
+        <p:nvSpPr>
+          <p:cNvPr id="6" name="TextBox 5"/>
+          <p:cNvSpPr txBox="1"/>
+          <p:nvPr/>
+        </p:nvSpPr>
+        <p:spPr>
+          <a:xfrm>
+            <a:off x="1097280" y="2834640"/>
+            <a:ext cx="4572000" cy="365760"/>
+          </a:xfrm>
+          <a:prstGeom prst="rect">
+            <a:avLst/>
+          </a:prstGeom>
+          <a:noFill/>
+        </p:spPr>
+        <p:txBody>
+          <a:bodyPr wrap="square">
+            <a:spAutoFit/>
+          </a:bodyPr>
+          <a:lstStyle/>
+          <a:p>
+            <a:pPr algn="l">
+              <a:defRPr sz="1200" b="0" i="0">
+                <a:solidFill>
+                  <a:srgbClr val="8F95A3"/>
+                </a:solidFill>
+                <a:latin typeface="Calibri"/>
+              </a:defRPr>
+            </a:pPr>
+            <a:r>
+              <a:t>AI tools built</a:t>
+            </a:r>
+          </a:p>
+        </p:txBody>
+      </p:sp>
+      <p:sp>
+        <p:nvSpPr>
+          <p:cNvPr id="7" name="TextBox 6"/>
+          <p:cNvSpPr txBox="1"/>
+          <p:nvPr/>
+        </p:nvSpPr>
+        <p:spPr>
+          <a:xfrm>
+            <a:off x="1097280" y="3291840"/>
+            <a:ext cx="9966960" cy="365760"/>
+          </a:xfrm>
+          <a:prstGeom prst="rect">
+            <a:avLst/>
+          </a:prstGeom>
+          <a:noFill/>
+        </p:spPr>
+        <p:txBody>
+          <a:bodyPr wrap="square">
+            <a:spAutoFit/>
+          </a:bodyPr>
+          <a:lstStyle/>
+          <a:p>
+            <a:pPr algn="l">
+              <a:defRPr sz="1400" b="0" i="0">
+                <a:solidFill>
+                  <a:srgbClr val="E2E2EA"/>
+                </a:solidFill>
+                <a:latin typeface="Calibri"/>
+              </a:defRPr>
+            </a:pPr>
+            <a:r>
+              <a:t>by Non-engineering teams</a:t>
+            </a:r>
+          </a:p>
+        </p:txBody>
+      </p:sp>
+      <p:sp>
+        <p:nvSpPr>
+          <p:cNvPr id="8" name="TextBox 7"/>
+          <p:cNvSpPr txBox="1"/>
+          <p:nvPr/>
+        </p:nvSpPr>
+        <p:spPr>
+          <a:xfrm>
+            <a:off x="1097280" y="3840480"/>
+            <a:ext cx="9966960" cy="457200"/>
+          </a:xfrm>
+          <a:prstGeom prst="rect">
+            <a:avLst/>
+          </a:prstGeom>
+          <a:noFill/>
+        </p:spPr>
+        <p:txBody>
+          <a:bodyPr wrap="square">
+            <a:spAutoFit/>
+          </a:bodyPr>
+          <a:lstStyle/>
+          <a:p>
+            <a:pPr algn="l">
+              <a:defRPr sz="1800" b="1" i="0">
                 <a:solidFill>
                   <a:srgbClr val="FFFFFF"/>
                 </a:solidFill>
@@ -6145,7 +6756,256 @@
               </a:defRPr>
             </a:pPr>
             <a:r>
-              <a:t>Kirill Khramkov</a:t>
+              <a:t>Everyone's Building the Future</a:t>
+            </a:r>
+          </a:p>
+        </p:txBody>
+      </p:sp>
+      <p:sp>
+        <p:nvSpPr>
+          <p:cNvPr id="9" name="TextBox 8"/>
+          <p:cNvSpPr txBox="1"/>
+          <p:nvPr/>
+        </p:nvSpPr>
+        <p:spPr>
+          <a:xfrm>
+            <a:off x="1097280" y="4389120"/>
+            <a:ext cx="9966960" cy="914400"/>
+          </a:xfrm>
+          <a:prstGeom prst="rect">
+            <a:avLst/>
+          </a:prstGeom>
+          <a:noFill/>
+        </p:spPr>
+        <p:txBody>
+          <a:bodyPr wrap="square">
+            <a:spAutoFit/>
+          </a:bodyPr>
+          <a:lstStyle/>
+          <a:p>
+            <a:pPr algn="l">
+              <a:defRPr sz="1400" b="0" i="0">
+                <a:solidFill>
+                  <a:srgbClr val="E2E2EA"/>
+                </a:solidFill>
+                <a:latin typeface="Calibri"/>
+              </a:defRPr>
+            </a:pPr>
+            <a:r>
+              <a:t>Our non-engineering teams have created countless useful AI tools, proving we're all builders now. This rapid innovation shows we're learning fast and moving in the right direction.</a:t>
+            </a:r>
+          </a:p>
+        </p:txBody>
+      </p:sp>
+      <p:sp>
+        <p:nvSpPr>
+          <p:cNvPr id="10" name="TextBox 9"/>
+          <p:cNvSpPr txBox="1"/>
+          <p:nvPr/>
+        </p:nvSpPr>
+        <p:spPr>
+          <a:xfrm>
+            <a:off x="1097280" y="5486400"/>
+            <a:ext cx="9966960" cy="457200"/>
+          </a:xfrm>
+          <a:prstGeom prst="rect">
+            <a:avLst/>
+          </a:prstGeom>
+          <a:noFill/>
+        </p:spPr>
+        <p:txBody>
+          <a:bodyPr wrap="square">
+            <a:spAutoFit/>
+          </a:bodyPr>
+          <a:lstStyle/>
+          <a:p>
+            <a:pPr algn="l">
+              <a:defRPr sz="1300" b="0" i="1">
+                <a:solidFill>
+                  <a:srgbClr val="8F95A3"/>
+                </a:solidFill>
+                <a:latin typeface="Calibri"/>
+              </a:defRPr>
+            </a:pPr>
+            <a:r>
+              <a:t>💬 "When everyone builds, everyone wins"</a:t>
+            </a:r>
+          </a:p>
+        </p:txBody>
+      </p:sp>
+    </p:spTree>
+  </p:cSld>
+  <p:clrMapOvr>
+    <a:masterClrMapping/>
+  </p:clrMapOvr>
+</p:sld>
+</file>
+
+<file path=ppt/slides/slide20.xml><?xml version="1.0" encoding="utf-8"?>
+<p:sld xmlns:a="http://schemas.openxmlformats.org/drawingml/2006/main" xmlns:p="http://schemas.openxmlformats.org/presentationml/2006/main" xmlns:r="http://schemas.openxmlformats.org/officeDocument/2006/relationships">
+  <p:cSld>
+    <p:bg>
+      <p:bgPr>
+        <a:solidFill>
+          <a:srgbClr val="08080C"/>
+        </a:solidFill>
+        <a:effectLst/>
+      </p:bgPr>
+    </p:bg>
+    <p:spTree>
+      <p:nvGrpSpPr>
+        <p:cNvPr id="1" name=""/>
+        <p:cNvGrpSpPr/>
+        <p:nvPr/>
+      </p:nvGrpSpPr>
+      <p:grpSpPr/>
+      <p:sp>
+        <p:nvSpPr>
+          <p:cNvPr id="2" name="Rectangle 1"/>
+          <p:cNvSpPr/>
+          <p:nvPr/>
+        </p:nvSpPr>
+        <p:spPr>
+          <a:xfrm>
+            <a:off x="0" y="365760"/>
+            <a:ext cx="12191695" cy="54864"/>
+          </a:xfrm>
+          <a:prstGeom prst="rect">
+            <a:avLst/>
+          </a:prstGeom>
+          <a:solidFill>
+            <a:srgbClr val="EF4444"/>
+          </a:solidFill>
+          <a:ln>
+            <a:noFill/>
+          </a:ln>
+        </p:spPr>
+        <p:style>
+          <a:lnRef idx="1">
+            <a:schemeClr val="accent1"/>
+          </a:lnRef>
+          <a:fillRef idx="3">
+            <a:schemeClr val="accent1"/>
+          </a:fillRef>
+          <a:effectRef idx="2">
+            <a:schemeClr val="accent1"/>
+          </a:effectRef>
+          <a:fontRef idx="minor">
+            <a:schemeClr val="lt1"/>
+          </a:fontRef>
+        </p:style>
+        <p:txBody>
+          <a:bodyPr rtlCol="0" anchor="ctr"/>
+          <a:lstStyle/>
+          <a:p>
+            <a:pPr algn="ctr"/>
+          </a:p>
+        </p:txBody>
+      </p:sp>
+      <p:sp>
+        <p:nvSpPr>
+          <p:cNvPr id="3" name="TextBox 2"/>
+          <p:cNvSpPr txBox="1"/>
+          <p:nvPr/>
+        </p:nvSpPr>
+        <p:spPr>
+          <a:xfrm>
+            <a:off x="1097280" y="731520"/>
+            <a:ext cx="3657600" cy="365760"/>
+          </a:xfrm>
+          <a:prstGeom prst="rect">
+            <a:avLst/>
+          </a:prstGeom>
+          <a:noFill/>
+        </p:spPr>
+        <p:txBody>
+          <a:bodyPr wrap="none">
+            <a:spAutoFit/>
+          </a:bodyPr>
+          <a:lstStyle/>
+          <a:p>
+            <a:pPr algn="l">
+              <a:defRPr sz="1000" b="1">
+                <a:solidFill>
+                  <a:srgbClr val="EF4444"/>
+                </a:solidFill>
+                <a:latin typeface="Calibri"/>
+              </a:defRPr>
+            </a:pPr>
+            <a:r>
+              <a:t>🛡️  WIN</a:t>
+            </a:r>
+          </a:p>
+        </p:txBody>
+      </p:sp>
+      <p:sp>
+        <p:nvSpPr>
+          <p:cNvPr id="4" name="TextBox 3"/>
+          <p:cNvSpPr txBox="1"/>
+          <p:nvPr/>
+        </p:nvSpPr>
+        <p:spPr>
+          <a:xfrm>
+            <a:off x="1097280" y="1188720"/>
+            <a:ext cx="9966960" cy="731520"/>
+          </a:xfrm>
+          <a:prstGeom prst="rect">
+            <a:avLst/>
+          </a:prstGeom>
+          <a:noFill/>
+        </p:spPr>
+        <p:txBody>
+          <a:bodyPr wrap="square">
+            <a:spAutoFit/>
+          </a:bodyPr>
+          <a:lstStyle/>
+          <a:p>
+            <a:pPr algn="l">
+              <a:defRPr sz="3200" b="1" i="0">
+                <a:solidFill>
+                  <a:srgbClr val="EF4444"/>
+                </a:solidFill>
+                <a:latin typeface="Calibri"/>
+              </a:defRPr>
+            </a:pPr>
+            <a:r>
+              <a:t>Fraud Defense Victory</a:t>
+            </a:r>
+          </a:p>
+        </p:txBody>
+      </p:sp>
+      <p:sp>
+        <p:nvSpPr>
+          <p:cNvPr id="5" name="TextBox 4"/>
+          <p:cNvSpPr txBox="1"/>
+          <p:nvPr/>
+        </p:nvSpPr>
+        <p:spPr>
+          <a:xfrm>
+            <a:off x="1097280" y="2103120"/>
+            <a:ext cx="4572000" cy="822960"/>
+          </a:xfrm>
+          <a:prstGeom prst="rect">
+            <a:avLst/>
+          </a:prstGeom>
+          <a:noFill/>
+        </p:spPr>
+        <p:txBody>
+          <a:bodyPr wrap="square">
+            <a:spAutoFit/>
+          </a:bodyPr>
+          <a:lstStyle/>
+          <a:p>
+            <a:pPr algn="l">
+              <a:defRPr sz="4800" b="1" i="0">
+                <a:solidFill>
+                  <a:srgbClr val="EF4444"/>
+                </a:solidFill>
+                <a:latin typeface="Calibri"/>
+              </a:defRPr>
+            </a:pPr>
+            <a:r>
+              <a:t>4%</a:t>
             </a:r>
           </a:p>
         </p:txBody>
@@ -6158,7 +7018,43 @@
         </p:nvSpPr>
         <p:spPr>
           <a:xfrm>
-            <a:off x="1097280" y="2743200"/>
+            <a:off x="1097280" y="2834640"/>
+            <a:ext cx="4572000" cy="365760"/>
+          </a:xfrm>
+          <a:prstGeom prst="rect">
+            <a:avLst/>
+          </a:prstGeom>
+          <a:noFill/>
+        </p:spPr>
+        <p:txBody>
+          <a:bodyPr wrap="square">
+            <a:spAutoFit/>
+          </a:bodyPr>
+          <a:lstStyle/>
+          <a:p>
+            <a:pPr algn="l">
+              <a:defRPr sz="1200" b="0" i="0">
+                <a:solidFill>
+                  <a:srgbClr val="8F95A3"/>
+                </a:solidFill>
+                <a:latin typeface="Calibri"/>
+              </a:defRPr>
+            </a:pPr>
+            <a:r>
+              <a:t>fraud rate</a:t>
+            </a:r>
+          </a:p>
+        </p:txBody>
+      </p:sp>
+      <p:sp>
+        <p:nvSpPr>
+          <p:cNvPr id="7" name="TextBox 6"/>
+          <p:cNvSpPr txBox="1"/>
+          <p:nvPr/>
+        </p:nvSpPr>
+        <p:spPr>
+          <a:xfrm>
+            <a:off x="1097280" y="3291840"/>
             <a:ext cx="9966960" cy="365760"/>
           </a:xfrm>
           <a:prstGeom prst="rect">
@@ -6175,85 +7071,121 @@
             <a:pPr algn="l">
               <a:defRPr sz="1400" b="0" i="0">
                 <a:solidFill>
+                  <a:srgbClr val="E2E2EA"/>
+                </a:solidFill>
+                <a:latin typeface="Calibri"/>
+              </a:defRPr>
+            </a:pPr>
+            <a:r>
+              <a:t>by Security Team</a:t>
+            </a:r>
+          </a:p>
+        </p:txBody>
+      </p:sp>
+      <p:sp>
+        <p:nvSpPr>
+          <p:cNvPr id="8" name="TextBox 7"/>
+          <p:cNvSpPr txBox="1"/>
+          <p:nvPr/>
+        </p:nvSpPr>
+        <p:spPr>
+          <a:xfrm>
+            <a:off x="1097280" y="3840480"/>
+            <a:ext cx="9966960" cy="457200"/>
+          </a:xfrm>
+          <a:prstGeom prst="rect">
+            <a:avLst/>
+          </a:prstGeom>
+          <a:noFill/>
+        </p:spPr>
+        <p:txBody>
+          <a:bodyPr wrap="square">
+            <a:spAutoFit/>
+          </a:bodyPr>
+          <a:lstStyle/>
+          <a:p>
+            <a:pPr algn="l">
+              <a:defRPr sz="1800" b="1" i="0">
+                <a:solidFill>
+                  <a:srgbClr val="FFFFFF"/>
+                </a:solidFill>
+                <a:latin typeface="Calibri"/>
+              </a:defRPr>
+            </a:pPr>
+            <a:r>
+              <a:t>Fraud Crushed: 22% → 4%</a:t>
+            </a:r>
+          </a:p>
+        </p:txBody>
+      </p:sp>
+      <p:sp>
+        <p:nvSpPr>
+          <p:cNvPr id="9" name="TextBox 8"/>
+          <p:cNvSpPr txBox="1"/>
+          <p:nvPr/>
+        </p:nvSpPr>
+        <p:spPr>
+          <a:xfrm>
+            <a:off x="1097280" y="4389120"/>
+            <a:ext cx="9966960" cy="914400"/>
+          </a:xfrm>
+          <a:prstGeom prst="rect">
+            <a:avLst/>
+          </a:prstGeom>
+          <a:noFill/>
+        </p:spPr>
+        <p:txBody>
+          <a:bodyPr wrap="square">
+            <a:spAutoFit/>
+          </a:bodyPr>
+          <a:lstStyle/>
+          <a:p>
+            <a:pPr algn="l">
+              <a:defRPr sz="1400" b="0" i="0">
+                <a:solidFill>
+                  <a:srgbClr val="E2E2EA"/>
+                </a:solidFill>
+                <a:latin typeface="Calibri"/>
+              </a:defRPr>
+            </a:pPr>
+            <a:r>
+              <a:t>Dynamic SDK signatures reduced fraud from 22% to under 4%. Our advanced security measures are protecting revenue and maintaining platform integrity.</a:t>
+            </a:r>
+          </a:p>
+        </p:txBody>
+      </p:sp>
+      <p:sp>
+        <p:nvSpPr>
+          <p:cNvPr id="10" name="TextBox 9"/>
+          <p:cNvSpPr txBox="1"/>
+          <p:nvPr/>
+        </p:nvSpPr>
+        <p:spPr>
+          <a:xfrm>
+            <a:off x="1097280" y="5486400"/>
+            <a:ext cx="9966960" cy="457200"/>
+          </a:xfrm>
+          <a:prstGeom prst="rect">
+            <a:avLst/>
+          </a:prstGeom>
+          <a:noFill/>
+        </p:spPr>
+        <p:txBody>
+          <a:bodyPr wrap="square">
+            <a:spAutoFit/>
+          </a:bodyPr>
+          <a:lstStyle/>
+          <a:p>
+            <a:pPr algn="l">
+              <a:defRPr sz="1300" b="0" i="1">
+                <a:solidFill>
                   <a:srgbClr val="8F95A3"/>
                 </a:solidFill>
                 <a:latin typeface="Calibri"/>
               </a:defRPr>
             </a:pPr>
             <a:r>
-              <a:t>March 14, 2026</a:t>
-            </a:r>
-          </a:p>
-        </p:txBody>
-      </p:sp>
-      <p:sp>
-        <p:nvSpPr>
-          <p:cNvPr id="7" name="TextBox 6"/>
-          <p:cNvSpPr txBox="1"/>
-          <p:nvPr/>
-        </p:nvSpPr>
-        <p:spPr>
-          <a:xfrm>
-            <a:off x="1097280" y="3291840"/>
-            <a:ext cx="9966960" cy="914400"/>
-          </a:xfrm>
-          <a:prstGeom prst="rect">
-            <a:avLst/>
-          </a:prstGeom>
-          <a:noFill/>
-        </p:spPr>
-        <p:txBody>
-          <a:bodyPr wrap="square">
-            <a:spAutoFit/>
-          </a:bodyPr>
-          <a:lstStyle/>
-          <a:p>
-            <a:pPr algn="l">
-              <a:defRPr sz="1600" b="0" i="0">
-                <a:solidFill>
-                  <a:srgbClr val="E2E2EA"/>
-                </a:solidFill>
-                <a:latin typeface="Calibri"/>
-              </a:defRPr>
-            </a:pPr>
-            <a:r>
-              <a:t>Thanks, everyone — your warm wishes truly made my day special!</a:t>
-            </a:r>
-          </a:p>
-        </p:txBody>
-      </p:sp>
-      <p:sp>
-        <p:nvSpPr>
-          <p:cNvPr id="8" name="TextBox 7"/>
-          <p:cNvSpPr txBox="1"/>
-          <p:nvPr/>
-        </p:nvSpPr>
-        <p:spPr>
-          <a:xfrm>
-            <a:off x="1097280" y="4572000"/>
-            <a:ext cx="9966960" cy="457200"/>
-          </a:xfrm>
-          <a:prstGeom prst="rect">
-            <a:avLst/>
-          </a:prstGeom>
-          <a:noFill/>
-        </p:spPr>
-        <p:txBody>
-          <a:bodyPr wrap="square">
-            <a:spAutoFit/>
-          </a:bodyPr>
-          <a:lstStyle/>
-          <a:p>
-            <a:pPr algn="l">
-              <a:defRPr sz="1400" b="0" i="1">
-                <a:solidFill>
-                  <a:srgbClr val="FF6B9D"/>
-                </a:solidFill>
-                <a:latin typeface="Calibri"/>
-              </a:defRPr>
-            </a:pPr>
-            <a:r>
-              <a:t>Engineering Team</a:t>
+              <a:t>💬 "Smart security = clean revenue"</a:t>
             </a:r>
           </a:p>
         </p:txBody>
@@ -6299,7 +7231,7 @@
             <a:avLst/>
           </a:prstGeom>
           <a:solidFill>
-            <a:srgbClr val="4ECDC4"/>
+            <a:srgbClr val="22C55E"/>
           </a:solidFill>
           <a:ln>
             <a:noFill/>
@@ -6352,13 +7284,13 @@
             <a:pPr algn="l">
               <a:defRPr sz="1000" b="1">
                 <a:solidFill>
-                  <a:srgbClr val="4ECDC4"/>
-                </a:solidFill>
-                <a:latin typeface="Calibri"/>
-              </a:defRPr>
-            </a:pPr>
-            <a:r>
-              <a:t>👏  CLAPS</a:t>
+                  <a:srgbClr val="22C55E"/>
+                </a:solidFill>
+                <a:latin typeface="Calibri"/>
+              </a:defRPr>
+            </a:pPr>
+            <a:r>
+              <a:t>🌱  EVENT</a:t>
             </a:r>
           </a:p>
         </p:txBody>
@@ -6388,13 +7320,13 @@
             <a:pPr algn="l">
               <a:defRPr sz="3200" b="1" i="0">
                 <a:solidFill>
-                  <a:srgbClr val="4ECDC4"/>
-                </a:solidFill>
-                <a:latin typeface="Calibri"/>
-              </a:defRPr>
-            </a:pPr>
-            <a:r>
-              <a:t>Recognition</a:t>
+                  <a:srgbClr val="22C55E"/>
+                </a:solidFill>
+                <a:latin typeface="Calibri"/>
+              </a:defRPr>
+            </a:pPr>
+            <a:r>
+              <a:t>Spring Connections Open</a:t>
             </a:r>
           </a:p>
         </p:txBody>
@@ -6408,29 +7340,29 @@
         <p:spPr>
           <a:xfrm>
             <a:off x="1097280" y="2103120"/>
-            <a:ext cx="2743200" cy="548640"/>
-          </a:xfrm>
-          <a:prstGeom prst="rect">
-            <a:avLst/>
-          </a:prstGeom>
-          <a:noFill/>
-        </p:spPr>
-        <p:txBody>
-          <a:bodyPr wrap="square">
-            <a:spAutoFit/>
-          </a:bodyPr>
-          <a:lstStyle/>
-          <a:p>
-            <a:pPr algn="l">
-              <a:defRPr sz="2800" b="1" i="0">
-                <a:solidFill>
-                  <a:srgbClr val="4ECDC4"/>
-                </a:solidFill>
-                <a:latin typeface="Calibri"/>
-              </a:defRPr>
-            </a:pPr>
-            <a:r>
-              <a:t>50</a:t>
+            <a:ext cx="9966960" cy="548640"/>
+          </a:xfrm>
+          <a:prstGeom prst="rect">
+            <a:avLst/>
+          </a:prstGeom>
+          <a:noFill/>
+        </p:spPr>
+        <p:txBody>
+          <a:bodyPr wrap="square">
+            <a:spAutoFit/>
+          </a:bodyPr>
+          <a:lstStyle/>
+          <a:p>
+            <a:pPr algn="l">
+              <a:defRPr sz="2200" b="1" i="0">
+                <a:solidFill>
+                  <a:srgbClr val="FFFFFF"/>
+                </a:solidFill>
+                <a:latin typeface="Calibri"/>
+              </a:defRPr>
+            </a:pPr>
+            <a:r>
+              <a:t>Connect Groups Spring Season</a:t>
             </a:r>
           </a:p>
         </p:txBody>
@@ -6443,7 +7375,7 @@
         </p:nvSpPr>
         <p:spPr>
           <a:xfrm>
-            <a:off x="1097280" y="2651760"/>
+            <a:off x="1097280" y="2743200"/>
             <a:ext cx="9966960" cy="365760"/>
           </a:xfrm>
           <a:prstGeom prst="rect">
@@ -6458,7 +7390,43 @@
           <a:lstStyle/>
           <a:p>
             <a:pPr algn="l">
-              <a:defRPr sz="1400" b="0" i="0">
+              <a:defRPr sz="1400" b="1" i="0">
+                <a:solidFill>
+                  <a:srgbClr val="22C55E"/>
+                </a:solidFill>
+                <a:latin typeface="Calibri"/>
+              </a:defRPr>
+            </a:pPr>
+            <a:r>
+              <a:t>March–May 2026</a:t>
+            </a:r>
+          </a:p>
+        </p:txBody>
+      </p:sp>
+      <p:sp>
+        <p:nvSpPr>
+          <p:cNvPr id="7" name="TextBox 6"/>
+          <p:cNvSpPr txBox="1"/>
+          <p:nvPr/>
+        </p:nvSpPr>
+        <p:spPr>
+          <a:xfrm>
+            <a:off x="1097280" y="3291840"/>
+            <a:ext cx="9966960" cy="1371600"/>
+          </a:xfrm>
+          <a:prstGeom prst="rect">
+            <a:avLst/>
+          </a:prstGeom>
+          <a:noFill/>
+        </p:spPr>
+        <p:txBody>
+          <a:bodyPr wrap="square">
+            <a:spAutoFit/>
+          </a:bodyPr>
+          <a:lstStyle/>
+          <a:p>
+            <a:pPr algn="l">
+              <a:defRPr sz="1500" b="0" i="0">
                 <a:solidFill>
                   <a:srgbClr val="E2E2EA"/>
                 </a:solidFill>
@@ -6466,20 +7434,20 @@
               </a:defRPr>
             </a:pPr>
             <a:r>
-              <a:t>from Mykhailo Kukharskyi</a:t>
-            </a:r>
-          </a:p>
-        </p:txBody>
-      </p:sp>
-      <p:sp>
-        <p:nvSpPr>
-          <p:cNvPr id="7" name="TextBox 6"/>
-          <p:cNvSpPr txBox="1"/>
-          <p:nvPr/>
-        </p:nvSpPr>
-        <p:spPr>
-          <a:xfrm>
-            <a:off x="1097280" y="3108960"/>
+              <a:t>Employee-led communities on Circle where we connect around shared interests, learning, and ideas — from sports and books to leadership, games, and meaningful conversations. Season officially launched!</a:t>
+            </a:r>
+          </a:p>
+        </p:txBody>
+      </p:sp>
+      <p:sp>
+        <p:nvSpPr>
+          <p:cNvPr id="8" name="TextBox 7"/>
+          <p:cNvSpPr txBox="1"/>
+          <p:nvPr/>
+        </p:nvSpPr>
+        <p:spPr>
+          <a:xfrm>
+            <a:off x="1097280" y="5029200"/>
             <a:ext cx="9966960" cy="365760"/>
           </a:xfrm>
           <a:prstGeom prst="rect">
@@ -6494,87 +7462,15 @@
           <a:lstStyle/>
           <a:p>
             <a:pPr algn="l">
-              <a:defRPr sz="1400" b="1" i="0">
-                <a:solidFill>
-                  <a:srgbClr val="FFFFFF"/>
-                </a:solidFill>
-                <a:latin typeface="Calibri"/>
-              </a:defRPr>
-            </a:pPr>
-            <a:r>
-              <a:t>to: Gleb Krahotkin</a:t>
-            </a:r>
-          </a:p>
-        </p:txBody>
-      </p:sp>
-      <p:sp>
-        <p:nvSpPr>
-          <p:cNvPr id="8" name="TextBox 7"/>
-          <p:cNvSpPr txBox="1"/>
-          <p:nvPr/>
-        </p:nvSpPr>
-        <p:spPr>
-          <a:xfrm>
-            <a:off x="1097280" y="3749039"/>
-            <a:ext cx="9966960" cy="1097280"/>
-          </a:xfrm>
-          <a:prstGeom prst="rect">
-            <a:avLst/>
-          </a:prstGeom>
-          <a:noFill/>
-        </p:spPr>
-        <p:txBody>
-          <a:bodyPr wrap="square">
-            <a:spAutoFit/>
-          </a:bodyPr>
-          <a:lstStyle/>
-          <a:p>
-            <a:pPr algn="l">
-              <a:defRPr sz="1500" b="0" i="1">
-                <a:solidFill>
-                  <a:srgbClr val="E2E2EA"/>
-                </a:solidFill>
-                <a:latin typeface="Calibri"/>
-              </a:defRPr>
-            </a:pPr>
-            <a:r>
-              <a:t>"Outstanding DevOps innovation with Coolify deployment platform"</a:t>
-            </a:r>
-          </a:p>
-        </p:txBody>
-      </p:sp>
-      <p:sp>
-        <p:nvSpPr>
-          <p:cNvPr id="9" name="TextBox 8"/>
-          <p:cNvSpPr txBox="1"/>
-          <p:nvPr/>
-        </p:nvSpPr>
-        <p:spPr>
-          <a:xfrm>
-            <a:off x="1097280" y="5120640"/>
-            <a:ext cx="9966960" cy="457200"/>
-          </a:xfrm>
-          <a:prstGeom prst="rect">
-            <a:avLst/>
-          </a:prstGeom>
-          <a:noFill/>
-        </p:spPr>
-        <p:txBody>
-          <a:bodyPr wrap="square">
-            <a:spAutoFit/>
-          </a:bodyPr>
-          <a:lstStyle/>
-          <a:p>
-            <a:pPr algn="l">
-              <a:defRPr sz="1200" b="1" i="0">
-                <a:solidFill>
-                  <a:srgbClr val="4ECDC4"/>
-                </a:solidFill>
-                <a:latin typeface="Calibri"/>
-              </a:defRPr>
-            </a:pPr>
-            <a:r>
-              <a:t>Innovation · Excellence</a:t>
+              <a:defRPr sz="1300" b="0" i="0">
+                <a:solidFill>
+                  <a:srgbClr val="8F95A3"/>
+                </a:solidFill>
+                <a:latin typeface="Calibri"/>
+              </a:defRPr>
+            </a:pPr>
+            <a:r>
+              <a:t>Organized by Katarzyna Raniszewska</a:t>
             </a:r>
           </a:p>
         </p:txBody>
@@ -6620,7 +7516,7 @@
             <a:avLst/>
           </a:prstGeom>
           <a:solidFill>
-            <a:srgbClr val="FFB74D"/>
+            <a:srgbClr val="8B5CF6"/>
           </a:solidFill>
           <a:ln>
             <a:noFill/>
@@ -6673,13 +7569,13 @@
             <a:pPr algn="l">
               <a:defRPr sz="1000" b="1">
                 <a:solidFill>
-                  <a:srgbClr val="FFB74D"/>
-                </a:solidFill>
-                <a:latin typeface="Calibri"/>
-              </a:defRPr>
-            </a:pPr>
-            <a:r>
-              <a:t>🔥  CLAPS</a:t>
+                  <a:srgbClr val="8B5CF6"/>
+                </a:solidFill>
+                <a:latin typeface="Calibri"/>
+              </a:defRPr>
+            </a:pPr>
+            <a:r>
+              <a:t>⚡  MILESTONE</a:t>
             </a:r>
           </a:p>
         </p:txBody>
@@ -6709,13 +7605,13 @@
             <a:pPr algn="l">
               <a:defRPr sz="3200" b="1" i="0">
                 <a:solidFill>
-                  <a:srgbClr val="FFB74D"/>
-                </a:solidFill>
-                <a:latin typeface="Calibri"/>
-              </a:defRPr>
-            </a:pPr>
-            <a:r>
-              <a:t>Team Recognition</a:t>
+                  <a:srgbClr val="8B5CF6"/>
+                </a:solidFill>
+                <a:latin typeface="Calibri"/>
+              </a:defRPr>
+            </a:pPr>
+            <a:r>
+              <a:t>DevOps Magic Unleashed</a:t>
             </a:r>
           </a:p>
         </p:txBody>
@@ -6729,29 +7625,29 @@
         <p:spPr>
           <a:xfrm>
             <a:off x="1097280" y="2103120"/>
-            <a:ext cx="2743200" cy="548640"/>
-          </a:xfrm>
-          <a:prstGeom prst="rect">
-            <a:avLst/>
-          </a:prstGeom>
-          <a:noFill/>
-        </p:spPr>
-        <p:txBody>
-          <a:bodyPr wrap="square">
-            <a:spAutoFit/>
-          </a:bodyPr>
-          <a:lstStyle/>
-          <a:p>
-            <a:pPr algn="l">
-              <a:defRPr sz="2800" b="1" i="0">
-                <a:solidFill>
-                  <a:srgbClr val="FFB74D"/>
-                </a:solidFill>
-                <a:latin typeface="Calibri"/>
-              </a:defRPr>
-            </a:pPr>
-            <a:r>
-              <a:t>50</a:t>
+            <a:ext cx="4572000" cy="822960"/>
+          </a:xfrm>
+          <a:prstGeom prst="rect">
+            <a:avLst/>
+          </a:prstGeom>
+          <a:noFill/>
+        </p:spPr>
+        <p:txBody>
+          <a:bodyPr wrap="square">
+            <a:spAutoFit/>
+          </a:bodyPr>
+          <a:lstStyle/>
+          <a:p>
+            <a:pPr algn="l">
+              <a:defRPr sz="5200" b="1" i="0">
+                <a:solidFill>
+                  <a:srgbClr val="8B5CF6"/>
+                </a:solidFill>
+                <a:latin typeface="Calibri"/>
+              </a:defRPr>
+            </a:pPr>
+            <a:r>
+              <a:t>100+</a:t>
             </a:r>
           </a:p>
         </p:txBody>
@@ -6764,22 +7660,94 @@
         </p:nvSpPr>
         <p:spPr>
           <a:xfrm>
-            <a:off x="1097280" y="2651760"/>
-            <a:ext cx="9966960" cy="365760"/>
-          </a:xfrm>
-          <a:prstGeom prst="rect">
-            <a:avLst/>
-          </a:prstGeom>
-          <a:noFill/>
-        </p:spPr>
-        <p:txBody>
-          <a:bodyPr wrap="square">
-            <a:spAutoFit/>
-          </a:bodyPr>
-          <a:lstStyle/>
-          <a:p>
-            <a:pPr algn="l">
-              <a:defRPr sz="1400" b="0" i="0">
+            <a:off x="1097280" y="2926080"/>
+            <a:ext cx="4572000" cy="365760"/>
+          </a:xfrm>
+          <a:prstGeom prst="rect">
+            <a:avLst/>
+          </a:prstGeom>
+          <a:noFill/>
+        </p:spPr>
+        <p:txBody>
+          <a:bodyPr wrap="square">
+            <a:spAutoFit/>
+          </a:bodyPr>
+          <a:lstStyle/>
+          <a:p>
+            <a:pPr algn="l">
+              <a:defRPr sz="1100" b="0" i="0">
+                <a:solidFill>
+                  <a:srgbClr val="8F95A3"/>
+                </a:solidFill>
+                <a:latin typeface="Calibri"/>
+              </a:defRPr>
+            </a:pPr>
+            <a:r>
+              <a:t>reactions &amp; celebrates</a:t>
+            </a:r>
+          </a:p>
+        </p:txBody>
+      </p:sp>
+      <p:sp>
+        <p:nvSpPr>
+          <p:cNvPr id="7" name="TextBox 6"/>
+          <p:cNvSpPr txBox="1"/>
+          <p:nvPr/>
+        </p:nvSpPr>
+        <p:spPr>
+          <a:xfrm>
+            <a:off x="1097280" y="3566160"/>
+            <a:ext cx="9966960" cy="457200"/>
+          </a:xfrm>
+          <a:prstGeom prst="rect">
+            <a:avLst/>
+          </a:prstGeom>
+          <a:noFill/>
+        </p:spPr>
+        <p:txBody>
+          <a:bodyPr wrap="square">
+            <a:spAutoFit/>
+          </a:bodyPr>
+          <a:lstStyle/>
+          <a:p>
+            <a:pPr algn="l">
+              <a:defRPr sz="1800" b="1" i="0">
+                <a:solidFill>
+                  <a:srgbClr val="FFFFFF"/>
+                </a:solidFill>
+                <a:latin typeface="Calibri"/>
+              </a:defRPr>
+            </a:pPr>
+            <a:r>
+              <a:t>One-Click Deployment Revolution</a:t>
+            </a:r>
+          </a:p>
+        </p:txBody>
+      </p:sp>
+      <p:sp>
+        <p:nvSpPr>
+          <p:cNvPr id="8" name="TextBox 7"/>
+          <p:cNvSpPr txBox="1"/>
+          <p:nvPr/>
+        </p:nvSpPr>
+        <p:spPr>
+          <a:xfrm>
+            <a:off x="1097280" y="4206240"/>
+            <a:ext cx="9966960" cy="1371600"/>
+          </a:xfrm>
+          <a:prstGeom prst="rect">
+            <a:avLst/>
+          </a:prstGeom>
+          <a:noFill/>
+        </p:spPr>
+        <p:txBody>
+          <a:bodyPr wrap="square">
+            <a:spAutoFit/>
+          </a:bodyPr>
+          <a:lstStyle/>
+          <a:p>
+            <a:pPr algn="l">
+              <a:defRPr sz="1500" b="0" i="0">
                 <a:solidFill>
                   <a:srgbClr val="E2E2EA"/>
                 </a:solidFill>
@@ -6787,115 +7755,7 @@
               </a:defRPr>
             </a:pPr>
             <a:r>
-              <a:t>from Viktor Trykolenko</a:t>
-            </a:r>
-          </a:p>
-        </p:txBody>
-      </p:sp>
-      <p:sp>
-        <p:nvSpPr>
-          <p:cNvPr id="7" name="TextBox 6"/>
-          <p:cNvSpPr txBox="1"/>
-          <p:nvPr/>
-        </p:nvSpPr>
-        <p:spPr>
-          <a:xfrm>
-            <a:off x="1097280" y="3108960"/>
-            <a:ext cx="9966960" cy="365760"/>
-          </a:xfrm>
-          <a:prstGeom prst="rect">
-            <a:avLst/>
-          </a:prstGeom>
-          <a:noFill/>
-        </p:spPr>
-        <p:txBody>
-          <a:bodyPr wrap="square">
-            <a:spAutoFit/>
-          </a:bodyPr>
-          <a:lstStyle/>
-          <a:p>
-            <a:pPr algn="l">
-              <a:defRPr sz="1400" b="1" i="0">
-                <a:solidFill>
-                  <a:srgbClr val="FFFFFF"/>
-                </a:solidFill>
-                <a:latin typeface="Calibri"/>
-              </a:defRPr>
-            </a:pPr>
-            <a:r>
-              <a:t>to: Iurii Kotov</a:t>
-            </a:r>
-          </a:p>
-        </p:txBody>
-      </p:sp>
-      <p:sp>
-        <p:nvSpPr>
-          <p:cNvPr id="8" name="TextBox 7"/>
-          <p:cNvSpPr txBox="1"/>
-          <p:nvPr/>
-        </p:nvSpPr>
-        <p:spPr>
-          <a:xfrm>
-            <a:off x="1097280" y="3749039"/>
-            <a:ext cx="9966960" cy="1097280"/>
-          </a:xfrm>
-          <a:prstGeom prst="rect">
-            <a:avLst/>
-          </a:prstGeom>
-          <a:noFill/>
-        </p:spPr>
-        <p:txBody>
-          <a:bodyPr wrap="square">
-            <a:spAutoFit/>
-          </a:bodyPr>
-          <a:lstStyle/>
-          <a:p>
-            <a:pPr algn="l">
-              <a:defRPr sz="1500" b="0" i="1">
-                <a:solidFill>
-                  <a:srgbClr val="E2E2EA"/>
-                </a:solidFill>
-                <a:latin typeface="Calibri"/>
-              </a:defRPr>
-            </a:pPr>
-            <a:r>
-              <a:t>"Exceptional technical leadership and project delivery"</a:t>
-            </a:r>
-          </a:p>
-        </p:txBody>
-      </p:sp>
-      <p:sp>
-        <p:nvSpPr>
-          <p:cNvPr id="9" name="TextBox 8"/>
-          <p:cNvSpPr txBox="1"/>
-          <p:nvPr/>
-        </p:nvSpPr>
-        <p:spPr>
-          <a:xfrm>
-            <a:off x="1097280" y="5120640"/>
-            <a:ext cx="9966960" cy="457200"/>
-          </a:xfrm>
-          <a:prstGeom prst="rect">
-            <a:avLst/>
-          </a:prstGeom>
-          <a:noFill/>
-        </p:spPr>
-        <p:txBody>
-          <a:bodyPr wrap="square">
-            <a:spAutoFit/>
-          </a:bodyPr>
-          <a:lstStyle/>
-          <a:p>
-            <a:pPr algn="l">
-              <a:defRPr sz="1200" b="1" i="0">
-                <a:solidFill>
-                  <a:srgbClr val="FFB74D"/>
-                </a:solidFill>
-                <a:latin typeface="Calibri"/>
-              </a:defRPr>
-            </a:pPr>
-            <a:r>
-              <a:t>Leadership · Delivery</a:t>
+              <a:t>Gleb and the DevOps team launched Coolify — deploy applications in just a few clicks. The community response has been explosive with massive engagement across all channels.</a:t>
             </a:r>
           </a:p>
         </p:txBody>
@@ -6941,7 +7801,7 @@
             <a:avLst/>
           </a:prstGeom>
           <a:solidFill>
-            <a:srgbClr val="9575CD"/>
+            <a:srgbClr val="06B6D4"/>
           </a:solidFill>
           <a:ln>
             <a:noFill/>
@@ -6994,13 +7854,13 @@
             <a:pPr algn="l">
               <a:defRPr sz="1000" b="1">
                 <a:solidFill>
-                  <a:srgbClr val="9575CD"/>
-                </a:solidFill>
-                <a:latin typeface="Calibri"/>
-              </a:defRPr>
-            </a:pPr>
-            <a:r>
-              <a:t>⭐  CLAPS</a:t>
+                  <a:srgbClr val="06B6D4"/>
+                </a:solidFill>
+                <a:latin typeface="Calibri"/>
+              </a:defRPr>
+            </a:pPr>
+            <a:r>
+              <a:t>🤖  WIN</a:t>
             </a:r>
           </a:p>
         </p:txBody>
@@ -7030,13 +7890,13 @@
             <a:pPr algn="l">
               <a:defRPr sz="3200" b="1" i="0">
                 <a:solidFill>
-                  <a:srgbClr val="9575CD"/>
-                </a:solidFill>
-                <a:latin typeface="Calibri"/>
-              </a:defRPr>
-            </a:pPr>
-            <a:r>
-              <a:t>Excellence</a:t>
+                  <a:srgbClr val="06B6D4"/>
+                </a:solidFill>
+                <a:latin typeface="Calibri"/>
+              </a:defRPr>
+            </a:pPr>
+            <a:r>
+              <a:t>Zero-Code AI Mastery</a:t>
             </a:r>
           </a:p>
         </p:txBody>
@@ -7050,29 +7910,29 @@
         <p:spPr>
           <a:xfrm>
             <a:off x="1097280" y="2103120"/>
-            <a:ext cx="2743200" cy="548640"/>
-          </a:xfrm>
-          <a:prstGeom prst="rect">
-            <a:avLst/>
-          </a:prstGeom>
-          <a:noFill/>
-        </p:spPr>
-        <p:txBody>
-          <a:bodyPr wrap="square">
-            <a:spAutoFit/>
-          </a:bodyPr>
-          <a:lstStyle/>
-          <a:p>
-            <a:pPr algn="l">
-              <a:defRPr sz="2800" b="1" i="0">
-                <a:solidFill>
-                  <a:srgbClr val="9575CD"/>
-                </a:solidFill>
-                <a:latin typeface="Calibri"/>
-              </a:defRPr>
-            </a:pPr>
-            <a:r>
-              <a:t>50</a:t>
+            <a:ext cx="4572000" cy="822960"/>
+          </a:xfrm>
+          <a:prstGeom prst="rect">
+            <a:avLst/>
+          </a:prstGeom>
+          <a:noFill/>
+        </p:spPr>
+        <p:txBody>
+          <a:bodyPr wrap="square">
+            <a:spAutoFit/>
+          </a:bodyPr>
+          <a:lstStyle/>
+          <a:p>
+            <a:pPr algn="l">
+              <a:defRPr sz="4800" b="1" i="0">
+                <a:solidFill>
+                  <a:srgbClr val="06B6D4"/>
+                </a:solidFill>
+                <a:latin typeface="Calibri"/>
+              </a:defRPr>
+            </a:pPr>
+            <a:r>
+              <a:t>100%</a:t>
             </a:r>
           </a:p>
         </p:txBody>
@@ -7085,7 +7945,43 @@
         </p:nvSpPr>
         <p:spPr>
           <a:xfrm>
-            <a:off x="1097280" y="2651760"/>
+            <a:off x="1097280" y="2834640"/>
+            <a:ext cx="4572000" cy="365760"/>
+          </a:xfrm>
+          <a:prstGeom prst="rect">
+            <a:avLst/>
+          </a:prstGeom>
+          <a:noFill/>
+        </p:spPr>
+        <p:txBody>
+          <a:bodyPr wrap="square">
+            <a:spAutoFit/>
+          </a:bodyPr>
+          <a:lstStyle/>
+          <a:p>
+            <a:pPr algn="l">
+              <a:defRPr sz="1200" b="0" i="0">
+                <a:solidFill>
+                  <a:srgbClr val="8F95A3"/>
+                </a:solidFill>
+                <a:latin typeface="Calibri"/>
+              </a:defRPr>
+            </a:pPr>
+            <a:r>
+              <a:t>AI-powered</a:t>
+            </a:r>
+          </a:p>
+        </p:txBody>
+      </p:sp>
+      <p:sp>
+        <p:nvSpPr>
+          <p:cNvPr id="7" name="TextBox 6"/>
+          <p:cNvSpPr txBox="1"/>
+          <p:nvPr/>
+        </p:nvSpPr>
+        <p:spPr>
+          <a:xfrm>
+            <a:off x="1097280" y="3291840"/>
             <a:ext cx="9966960" cy="365760"/>
           </a:xfrm>
           <a:prstGeom prst="rect">
@@ -7108,35 +8004,35 @@
               </a:defRPr>
             </a:pPr>
             <a:r>
-              <a:t>from Jasmine Nunez</a:t>
-            </a:r>
-          </a:p>
-        </p:txBody>
-      </p:sp>
-      <p:sp>
-        <p:nvSpPr>
-          <p:cNvPr id="7" name="TextBox 6"/>
-          <p:cNvSpPr txBox="1"/>
-          <p:nvPr/>
-        </p:nvSpPr>
-        <p:spPr>
-          <a:xfrm>
-            <a:off x="1097280" y="3108960"/>
-            <a:ext cx="9966960" cy="365760"/>
-          </a:xfrm>
-          <a:prstGeom prst="rect">
-            <a:avLst/>
-          </a:prstGeom>
-          <a:noFill/>
-        </p:spPr>
-        <p:txBody>
-          <a:bodyPr wrap="square">
-            <a:spAutoFit/>
-          </a:bodyPr>
-          <a:lstStyle/>
-          <a:p>
-            <a:pPr algn="l">
-              <a:defRPr sz="1400" b="1" i="0">
+              <a:t>by Liliya Garifullina</a:t>
+            </a:r>
+          </a:p>
+        </p:txBody>
+      </p:sp>
+      <p:sp>
+        <p:nvSpPr>
+          <p:cNvPr id="8" name="TextBox 7"/>
+          <p:cNvSpPr txBox="1"/>
+          <p:nvPr/>
+        </p:nvSpPr>
+        <p:spPr>
+          <a:xfrm>
+            <a:off x="1097280" y="3840480"/>
+            <a:ext cx="9966960" cy="457200"/>
+          </a:xfrm>
+          <a:prstGeom prst="rect">
+            <a:avLst/>
+          </a:prstGeom>
+          <a:noFill/>
+        </p:spPr>
+        <p:txBody>
+          <a:bodyPr wrap="square">
+            <a:spAutoFit/>
+          </a:bodyPr>
+          <a:lstStyle/>
+          <a:p>
+            <a:pPr algn="l">
+              <a:defRPr sz="1800" b="1" i="0">
                 <a:solidFill>
                   <a:srgbClr val="FFFFFF"/>
                 </a:solidFill>
@@ -7144,35 +8040,35 @@
               </a:defRPr>
             </a:pPr>
             <a:r>
-              <a:t>to: Michelle Walter</a:t>
-            </a:r>
-          </a:p>
-        </p:txBody>
-      </p:sp>
-      <p:sp>
-        <p:nvSpPr>
-          <p:cNvPr id="8" name="TextBox 7"/>
-          <p:cNvSpPr txBox="1"/>
-          <p:nvPr/>
-        </p:nvSpPr>
-        <p:spPr>
-          <a:xfrm>
-            <a:off x="1097280" y="3749039"/>
-            <a:ext cx="9966960" cy="1097280"/>
-          </a:xfrm>
-          <a:prstGeom prst="rect">
-            <a:avLst/>
-          </a:prstGeom>
-          <a:noFill/>
-        </p:spPr>
-        <p:txBody>
-          <a:bodyPr wrap="square">
-            <a:spAutoFit/>
-          </a:bodyPr>
-          <a:lstStyle/>
-          <a:p>
-            <a:pPr algn="l">
-              <a:defRPr sz="1500" b="0" i="1">
+              <a:t>From Slack to Live Dashboard</a:t>
+            </a:r>
+          </a:p>
+        </p:txBody>
+      </p:sp>
+      <p:sp>
+        <p:nvSpPr>
+          <p:cNvPr id="9" name="TextBox 8"/>
+          <p:cNvSpPr txBox="1"/>
+          <p:nvPr/>
+        </p:nvSpPr>
+        <p:spPr>
+          <a:xfrm>
+            <a:off x="1097280" y="4389120"/>
+            <a:ext cx="9966960" cy="914400"/>
+          </a:xfrm>
+          <a:prstGeom prst="rect">
+            <a:avLst/>
+          </a:prstGeom>
+          <a:noFill/>
+        </p:spPr>
+        <p:txBody>
+          <a:bodyPr wrap="square">
+            <a:spAutoFit/>
+          </a:bodyPr>
+          <a:lstStyle/>
+          <a:p>
+            <a:pPr algn="l">
+              <a:defRPr sz="1400" b="0" i="0">
                 <a:solidFill>
                   <a:srgbClr val="E2E2EA"/>
                 </a:solidFill>
@@ -7180,20 +8076,20 @@
               </a:defRPr>
             </a:pPr>
             <a:r>
-              <a:t>"Outstanding performance and dedication to quality"</a:t>
-            </a:r>
-          </a:p>
-        </p:txBody>
-      </p:sp>
-      <p:sp>
-        <p:nvSpPr>
-          <p:cNvPr id="9" name="TextBox 8"/>
-          <p:cNvSpPr txBox="1"/>
-          <p:nvPr/>
-        </p:nvSpPr>
-        <p:spPr>
-          <a:xfrm>
-            <a:off x="1097280" y="5120640"/>
+              <a:t>Built a fully automated AI system — Slack data curation to auto-deploying live office TVs — using only AI tools and zero coding experience. A perfect example of our democratized building culture.</a:t>
+            </a:r>
+          </a:p>
+        </p:txBody>
+      </p:sp>
+      <p:sp>
+        <p:nvSpPr>
+          <p:cNvPr id="10" name="TextBox 9"/>
+          <p:cNvSpPr txBox="1"/>
+          <p:nvPr/>
+        </p:nvSpPr>
+        <p:spPr>
+          <a:xfrm>
+            <a:off x="1097280" y="5486400"/>
             <a:ext cx="9966960" cy="457200"/>
           </a:xfrm>
           <a:prstGeom prst="rect">
@@ -7208,15 +8104,15 @@
           <a:lstStyle/>
           <a:p>
             <a:pPr algn="l">
-              <a:defRPr sz="1200" b="1" i="0">
-                <a:solidFill>
-                  <a:srgbClr val="9575CD"/>
-                </a:solidFill>
-                <a:latin typeface="Calibri"/>
-              </a:defRPr>
-            </a:pPr>
-            <a:r>
-              <a:t>Excellence · Quality</a:t>
+              <a:defRPr sz="1300" b="0" i="1">
+                <a:solidFill>
+                  <a:srgbClr val="8F95A3"/>
+                </a:solidFill>
+                <a:latin typeface="Calibri"/>
+              </a:defRPr>
+            </a:pPr>
+            <a:r>
+              <a:t>💬 "If she can do it, you can too"</a:t>
             </a:r>
           </a:p>
         </p:txBody>
@@ -7262,7 +8158,7 @@
             <a:avLst/>
           </a:prstGeom>
           <a:solidFill>
-            <a:srgbClr val="26C6DA"/>
+            <a:srgbClr val="F59E0B"/>
           </a:solidFill>
           <a:ln>
             <a:noFill/>
@@ -7315,13 +8211,13 @@
             <a:pPr algn="l">
               <a:defRPr sz="1000" b="1">
                 <a:solidFill>
-                  <a:srgbClr val="26C6DA"/>
-                </a:solidFill>
-                <a:latin typeface="Calibri"/>
-              </a:defRPr>
-            </a:pPr>
-            <a:r>
-              <a:t>🚀  CLAPS</a:t>
+                  <a:srgbClr val="F59E0B"/>
+                </a:solidFill>
+                <a:latin typeface="Calibri"/>
+              </a:defRPr>
+            </a:pPr>
+            <a:r>
+              <a:t>🎂  CELEBRATION</a:t>
             </a:r>
           </a:p>
         </p:txBody>
@@ -7351,13 +8247,13 @@
             <a:pPr algn="l">
               <a:defRPr sz="3200" b="1" i="0">
                 <a:solidFill>
-                  <a:srgbClr val="26C6DA"/>
-                </a:solidFill>
-                <a:latin typeface="Calibri"/>
-              </a:defRPr>
-            </a:pPr>
-            <a:r>
-              <a:t>Team Spirit</a:t>
+                  <a:srgbClr val="F59E0B"/>
+                </a:solidFill>
+                <a:latin typeface="Calibri"/>
+              </a:defRPr>
+            </a:pPr>
+            <a:r>
+              <a:t>Happy Birthday!</a:t>
             </a:r>
           </a:p>
         </p:txBody>
@@ -7371,7 +8267,7 @@
         <p:spPr>
           <a:xfrm>
             <a:off x="1097280" y="2103120"/>
-            <a:ext cx="2743200" cy="548640"/>
+            <a:ext cx="9966960" cy="640080"/>
           </a:xfrm>
           <a:prstGeom prst="rect">
             <a:avLst/>
@@ -7387,13 +8283,13 @@
             <a:pPr algn="l">
               <a:defRPr sz="2800" b="1" i="0">
                 <a:solidFill>
-                  <a:srgbClr val="26C6DA"/>
-                </a:solidFill>
-                <a:latin typeface="Calibri"/>
-              </a:defRPr>
-            </a:pPr>
-            <a:r>
-              <a:t>50</a:t>
+                  <a:srgbClr val="FFFFFF"/>
+                </a:solidFill>
+                <a:latin typeface="Calibri"/>
+              </a:defRPr>
+            </a:pPr>
+            <a:r>
+              <a:t>Kirill Khramkov</a:t>
             </a:r>
           </a:p>
         </p:txBody>
@@ -7406,7 +8302,7 @@
         </p:nvSpPr>
         <p:spPr>
           <a:xfrm>
-            <a:off x="1097280" y="2651760"/>
+            <a:off x="1097280" y="2743200"/>
             <a:ext cx="9966960" cy="365760"/>
           </a:xfrm>
           <a:prstGeom prst="rect">
@@ -7423,49 +8319,49 @@
             <a:pPr algn="l">
               <a:defRPr sz="1400" b="0" i="0">
                 <a:solidFill>
+                  <a:srgbClr val="8F95A3"/>
+                </a:solidFill>
+                <a:latin typeface="Calibri"/>
+              </a:defRPr>
+            </a:pPr>
+            <a:r>
+              <a:t>March 14, 2026</a:t>
+            </a:r>
+          </a:p>
+        </p:txBody>
+      </p:sp>
+      <p:sp>
+        <p:nvSpPr>
+          <p:cNvPr id="7" name="TextBox 6"/>
+          <p:cNvSpPr txBox="1"/>
+          <p:nvPr/>
+        </p:nvSpPr>
+        <p:spPr>
+          <a:xfrm>
+            <a:off x="1097280" y="3291840"/>
+            <a:ext cx="9966960" cy="914400"/>
+          </a:xfrm>
+          <a:prstGeom prst="rect">
+            <a:avLst/>
+          </a:prstGeom>
+          <a:noFill/>
+        </p:spPr>
+        <p:txBody>
+          <a:bodyPr wrap="square">
+            <a:spAutoFit/>
+          </a:bodyPr>
+          <a:lstStyle/>
+          <a:p>
+            <a:pPr algn="l">
+              <a:defRPr sz="1600" b="0" i="0">
+                <a:solidFill>
                   <a:srgbClr val="E2E2EA"/>
                 </a:solidFill>
                 <a:latin typeface="Calibri"/>
               </a:defRPr>
             </a:pPr>
             <a:r>
-              <a:t>from Michael Lotfy</a:t>
-            </a:r>
-          </a:p>
-        </p:txBody>
-      </p:sp>
-      <p:sp>
-        <p:nvSpPr>
-          <p:cNvPr id="7" name="TextBox 6"/>
-          <p:cNvSpPr txBox="1"/>
-          <p:nvPr/>
-        </p:nvSpPr>
-        <p:spPr>
-          <a:xfrm>
-            <a:off x="1097280" y="3108960"/>
-            <a:ext cx="9966960" cy="365760"/>
-          </a:xfrm>
-          <a:prstGeom prst="rect">
-            <a:avLst/>
-          </a:prstGeom>
-          <a:noFill/>
-        </p:spPr>
-        <p:txBody>
-          <a:bodyPr wrap="square">
-            <a:spAutoFit/>
-          </a:bodyPr>
-          <a:lstStyle/>
-          <a:p>
-            <a:pPr algn="l">
-              <a:defRPr sz="1400" b="1" i="0">
-                <a:solidFill>
-                  <a:srgbClr val="FFFFFF"/>
-                </a:solidFill>
-                <a:latin typeface="Calibri"/>
-              </a:defRPr>
-            </a:pPr>
-            <a:r>
-              <a:t>to: Isahakyan</a:t>
+              <a:t>Thanks, everyone — your warm wishes made my day extra special!</a:t>
             </a:r>
           </a:p>
         </p:txBody>
@@ -7478,43 +8374,7 @@
         </p:nvSpPr>
         <p:spPr>
           <a:xfrm>
-            <a:off x="1097280" y="3749039"/>
-            <a:ext cx="9966960" cy="1097280"/>
-          </a:xfrm>
-          <a:prstGeom prst="rect">
-            <a:avLst/>
-          </a:prstGeom>
-          <a:noFill/>
-        </p:spPr>
-        <p:txBody>
-          <a:bodyPr wrap="square">
-            <a:spAutoFit/>
-          </a:bodyPr>
-          <a:lstStyle/>
-          <a:p>
-            <a:pPr algn="l">
-              <a:defRPr sz="1500" b="0" i="1">
-                <a:solidFill>
-                  <a:srgbClr val="E2E2EA"/>
-                </a:solidFill>
-                <a:latin typeface="Calibri"/>
-              </a:defRPr>
-            </a:pPr>
-            <a:r>
-              <a:t>"Incredible teamwork and collaborative excellence"</a:t>
-            </a:r>
-          </a:p>
-        </p:txBody>
-      </p:sp>
-      <p:sp>
-        <p:nvSpPr>
-          <p:cNvPr id="9" name="TextBox 8"/>
-          <p:cNvSpPr txBox="1"/>
-          <p:nvPr/>
-        </p:nvSpPr>
-        <p:spPr>
-          <a:xfrm>
-            <a:off x="1097280" y="5120640"/>
+            <a:off x="1097280" y="4572000"/>
             <a:ext cx="9966960" cy="457200"/>
           </a:xfrm>
           <a:prstGeom prst="rect">
@@ -7529,15 +8389,15 @@
           <a:lstStyle/>
           <a:p>
             <a:pPr algn="l">
-              <a:defRPr sz="1200" b="1" i="0">
-                <a:solidFill>
-                  <a:srgbClr val="26C6DA"/>
-                </a:solidFill>
-                <a:latin typeface="Calibri"/>
-              </a:defRPr>
-            </a:pPr>
-            <a:r>
-              <a:t>Collaboration · Teamwork</a:t>
+              <a:defRPr sz="1400" b="0" i="1">
+                <a:solidFill>
+                  <a:srgbClr val="F59E0B"/>
+                </a:solidFill>
+                <a:latin typeface="Calibri"/>
+              </a:defRPr>
+            </a:pPr>
+            <a:r>
+              <a:t>Engineering • Barcelona</a:t>
             </a:r>
           </a:p>
         </p:txBody>
@@ -7583,7 +8443,7 @@
             <a:avLst/>
           </a:prstGeom>
           <a:solidFill>
-            <a:srgbClr val="66BB6A"/>
+            <a:srgbClr val="EC4899"/>
           </a:solidFill>
           <a:ln>
             <a:noFill/>
@@ -7636,13 +8496,13 @@
             <a:pPr algn="l">
               <a:defRPr sz="1000" b="1">
                 <a:solidFill>
-                  <a:srgbClr val="66BB6A"/>
-                </a:solidFill>
-                <a:latin typeface="Calibri"/>
-              </a:defRPr>
-            </a:pPr>
-            <a:r>
-              <a:t>💪  CLAPS</a:t>
+                  <a:srgbClr val="EC4899"/>
+                </a:solidFill>
+                <a:latin typeface="Calibri"/>
+              </a:defRPr>
+            </a:pPr>
+            <a:r>
+              <a:t>👏  CLAPS</a:t>
             </a:r>
           </a:p>
         </p:txBody>
@@ -7672,13 +8532,13 @@
             <a:pPr algn="l">
               <a:defRPr sz="3200" b="1" i="0">
                 <a:solidFill>
-                  <a:srgbClr val="66BB6A"/>
-                </a:solidFill>
-                <a:latin typeface="Calibri"/>
-              </a:defRPr>
-            </a:pPr>
-            <a:r>
-              <a:t>Engineering Excellence</a:t>
+                  <a:srgbClr val="EC4899"/>
+                </a:solidFill>
+                <a:latin typeface="Calibri"/>
+              </a:defRPr>
+            </a:pPr>
+            <a:r>
+              <a:t>DevOps Champion</a:t>
             </a:r>
           </a:p>
         </p:txBody>
@@ -7708,7 +8568,7 @@
             <a:pPr algn="l">
               <a:defRPr sz="2800" b="1" i="0">
                 <a:solidFill>
-                  <a:srgbClr val="66BB6A"/>
+                  <a:srgbClr val="EC4899"/>
                 </a:solidFill>
                 <a:latin typeface="Calibri"/>
               </a:defRPr>
@@ -7750,7 +8610,7 @@
               </a:defRPr>
             </a:pPr>
             <a:r>
-              <a:t>from Valentino Agazzi Mandozzi</a:t>
+              <a:t>from Mykhailo Kukharskyi</a:t>
             </a:r>
           </a:p>
         </p:txBody>
@@ -7786,7 +8646,7 @@
               </a:defRPr>
             </a:pPr>
             <a:r>
-              <a:t>to: Eren Sakarya</a:t>
+              <a:t>to: Gleb Krahotkin</a:t>
             </a:r>
           </a:p>
         </p:txBody>
@@ -7822,7 +8682,7 @@
               </a:defRPr>
             </a:pPr>
             <a:r>
-              <a:t>"Exceptional technical expertise and problem-solving"</a:t>
+              <a:t>"Outstanding work on Coolify deployment platform"</a:t>
             </a:r>
           </a:p>
         </p:txBody>
@@ -7852,13 +8712,13 @@
             <a:pPr algn="l">
               <a:defRPr sz="1200" b="1" i="0">
                 <a:solidFill>
-                  <a:srgbClr val="66BB6A"/>
-                </a:solidFill>
-                <a:latin typeface="Calibri"/>
-              </a:defRPr>
-            </a:pPr>
-            <a:r>
-              <a:t>Technical Excellence · Innovation</a:t>
+                  <a:srgbClr val="EC4899"/>
+                </a:solidFill>
+                <a:latin typeface="Calibri"/>
+              </a:defRPr>
+            </a:pPr>
+            <a:r>
+              <a:t>Innovation · Excellence</a:t>
             </a:r>
           </a:p>
         </p:txBody>
@@ -7904,7 +8764,7 @@
             <a:avLst/>
           </a:prstGeom>
           <a:solidFill>
-            <a:srgbClr val="FF7043"/>
+            <a:srgbClr val="EF4444"/>
           </a:solidFill>
           <a:ln>
             <a:noFill/>
@@ -7957,13 +8817,13 @@
             <a:pPr algn="l">
               <a:defRPr sz="1000" b="1">
                 <a:solidFill>
-                  <a:srgbClr val="FF7043"/>
-                </a:solidFill>
-                <a:latin typeface="Calibri"/>
-              </a:defRPr>
-            </a:pPr>
-            <a:r>
-              <a:t>🎯  WIN</a:t>
+                  <a:srgbClr val="EF4444"/>
+                </a:solidFill>
+                <a:latin typeface="Calibri"/>
+              </a:defRPr>
+            </a:pPr>
+            <a:r>
+              <a:t>🔥  CLAPS</a:t>
             </a:r>
           </a:p>
         </p:txBody>
@@ -7993,13 +8853,13 @@
             <a:pPr algn="l">
               <a:defRPr sz="3200" b="1" i="0">
                 <a:solidFill>
-                  <a:srgbClr val="FF7043"/>
-                </a:solidFill>
-                <a:latin typeface="Calibri"/>
-              </a:defRPr>
-            </a:pPr>
-            <a:r>
-              <a:t>DevOps Innovation</a:t>
+                  <a:srgbClr val="EF4444"/>
+                </a:solidFill>
+                <a:latin typeface="Calibri"/>
+              </a:defRPr>
+            </a:pPr>
+            <a:r>
+              <a:t>Technical Excellence</a:t>
             </a:r>
           </a:p>
         </p:txBody>
@@ -8013,29 +8873,29 @@
         <p:spPr>
           <a:xfrm>
             <a:off x="1097280" y="2103120"/>
-            <a:ext cx="4572000" cy="822960"/>
-          </a:xfrm>
-          <a:prstGeom prst="rect">
-            <a:avLst/>
-          </a:prstGeom>
-          <a:noFill/>
-        </p:spPr>
-        <p:txBody>
-          <a:bodyPr wrap="square">
-            <a:spAutoFit/>
-          </a:bodyPr>
-          <a:lstStyle/>
-          <a:p>
-            <a:pPr algn="l">
-              <a:defRPr sz="4800" b="1" i="0">
-                <a:solidFill>
-                  <a:srgbClr val="FF7043"/>
-                </a:solidFill>
-                <a:latin typeface="Calibri"/>
-              </a:defRPr>
-            </a:pPr>
-            <a:r>
-              <a:t>1-click</a:t>
+            <a:ext cx="2743200" cy="548640"/>
+          </a:xfrm>
+          <a:prstGeom prst="rect">
+            <a:avLst/>
+          </a:prstGeom>
+          <a:noFill/>
+        </p:spPr>
+        <p:txBody>
+          <a:bodyPr wrap="square">
+            <a:spAutoFit/>
+          </a:bodyPr>
+          <a:lstStyle/>
+          <a:p>
+            <a:pPr algn="l">
+              <a:defRPr sz="2800" b="1" i="0">
+                <a:solidFill>
+                  <a:srgbClr val="EF4444"/>
+                </a:solidFill>
+                <a:latin typeface="Calibri"/>
+              </a:defRPr>
+            </a:pPr>
+            <a:r>
+              <a:t>50</a:t>
             </a:r>
           </a:p>
         </p:txBody>
@@ -8048,30 +8908,30 @@
         </p:nvSpPr>
         <p:spPr>
           <a:xfrm>
-            <a:off x="1097280" y="2834640"/>
-            <a:ext cx="4572000" cy="365760"/>
-          </a:xfrm>
-          <a:prstGeom prst="rect">
-            <a:avLst/>
-          </a:prstGeom>
-          <a:noFill/>
-        </p:spPr>
-        <p:txBody>
-          <a:bodyPr wrap="square">
-            <a:spAutoFit/>
-          </a:bodyPr>
-          <a:lstStyle/>
-          <a:p>
-            <a:pPr algn="l">
-              <a:defRPr sz="1200" b="0" i="0">
-                <a:solidFill>
-                  <a:srgbClr val="8F95A3"/>
-                </a:solidFill>
-                <a:latin typeface="Calibri"/>
-              </a:defRPr>
-            </a:pPr>
-            <a:r>
-              <a:t>deployment</a:t>
+            <a:off x="1097280" y="2651760"/>
+            <a:ext cx="9966960" cy="365760"/>
+          </a:xfrm>
+          <a:prstGeom prst="rect">
+            <a:avLst/>
+          </a:prstGeom>
+          <a:noFill/>
+        </p:spPr>
+        <p:txBody>
+          <a:bodyPr wrap="square">
+            <a:spAutoFit/>
+          </a:bodyPr>
+          <a:lstStyle/>
+          <a:p>
+            <a:pPr algn="l">
+              <a:defRPr sz="1400" b="0" i="0">
+                <a:solidFill>
+                  <a:srgbClr val="E2E2EA"/>
+                </a:solidFill>
+                <a:latin typeface="Calibri"/>
+              </a:defRPr>
+            </a:pPr>
+            <a:r>
+              <a:t>from Viktor Trykolenko</a:t>
             </a:r>
           </a:p>
         </p:txBody>
@@ -8084,7 +8944,7 @@
         </p:nvSpPr>
         <p:spPr>
           <a:xfrm>
-            <a:off x="1097280" y="3291840"/>
+            <a:off x="1097280" y="3108960"/>
             <a:ext cx="9966960" cy="365760"/>
           </a:xfrm>
           <a:prstGeom prst="rect">
@@ -8099,7 +8959,43 @@
           <a:lstStyle/>
           <a:p>
             <a:pPr algn="l">
-              <a:defRPr sz="1400" b="0" i="0">
+              <a:defRPr sz="1400" b="1" i="0">
+                <a:solidFill>
+                  <a:srgbClr val="FFFFFF"/>
+                </a:solidFill>
+                <a:latin typeface="Calibri"/>
+              </a:defRPr>
+            </a:pPr>
+            <a:r>
+              <a:t>to: Iurii Kotov</a:t>
+            </a:r>
+          </a:p>
+        </p:txBody>
+      </p:sp>
+      <p:sp>
+        <p:nvSpPr>
+          <p:cNvPr id="8" name="TextBox 7"/>
+          <p:cNvSpPr txBox="1"/>
+          <p:nvPr/>
+        </p:nvSpPr>
+        <p:spPr>
+          <a:xfrm>
+            <a:off x="1097280" y="3749039"/>
+            <a:ext cx="9966960" cy="1097280"/>
+          </a:xfrm>
+          <a:prstGeom prst="rect">
+            <a:avLst/>
+          </a:prstGeom>
+          <a:noFill/>
+        </p:spPr>
+        <p:txBody>
+          <a:bodyPr wrap="square">
+            <a:spAutoFit/>
+          </a:bodyPr>
+          <a:lstStyle/>
+          <a:p>
+            <a:pPr algn="l">
+              <a:defRPr sz="1500" b="0" i="1">
                 <a:solidFill>
                   <a:srgbClr val="E2E2EA"/>
                 </a:solidFill>
@@ -8107,20 +9003,20 @@
               </a:defRPr>
             </a:pPr>
             <a:r>
-              <a:t>by Gleb Krahotkin</a:t>
-            </a:r>
-          </a:p>
-        </p:txBody>
-      </p:sp>
-      <p:sp>
-        <p:nvSpPr>
-          <p:cNvPr id="8" name="TextBox 7"/>
-          <p:cNvSpPr txBox="1"/>
-          <p:nvPr/>
-        </p:nvSpPr>
-        <p:spPr>
-          <a:xfrm>
-            <a:off x="1097280" y="3840480"/>
+              <a:t>"Exceptional technical leadership and innovation"</a:t>
+            </a:r>
+          </a:p>
+        </p:txBody>
+      </p:sp>
+      <p:sp>
+        <p:nvSpPr>
+          <p:cNvPr id="9" name="TextBox 8"/>
+          <p:cNvSpPr txBox="1"/>
+          <p:nvPr/>
+        </p:nvSpPr>
+        <p:spPr>
+          <a:xfrm>
+            <a:off x="1097280" y="5120640"/>
             <a:ext cx="9966960" cy="457200"/>
           </a:xfrm>
           <a:prstGeom prst="rect">
@@ -8135,87 +9031,15 @@
           <a:lstStyle/>
           <a:p>
             <a:pPr algn="l">
-              <a:defRPr sz="1800" b="1" i="0">
-                <a:solidFill>
-                  <a:srgbClr val="FFFFFF"/>
-                </a:solidFill>
-                <a:latin typeface="Calibri"/>
-              </a:defRPr>
-            </a:pPr>
-            <a:r>
-              <a:t>Coolify Platform Launch</a:t>
-            </a:r>
-          </a:p>
-        </p:txBody>
-      </p:sp>
-      <p:sp>
-        <p:nvSpPr>
-          <p:cNvPr id="9" name="TextBox 8"/>
-          <p:cNvSpPr txBox="1"/>
-          <p:nvPr/>
-        </p:nvSpPr>
-        <p:spPr>
-          <a:xfrm>
-            <a:off x="1097280" y="4389120"/>
-            <a:ext cx="9966960" cy="914400"/>
-          </a:xfrm>
-          <a:prstGeom prst="rect">
-            <a:avLst/>
-          </a:prstGeom>
-          <a:noFill/>
-        </p:spPr>
-        <p:txBody>
-          <a:bodyPr wrap="square">
-            <a:spAutoFit/>
-          </a:bodyPr>
-          <a:lstStyle/>
-          <a:p>
-            <a:pPr algn="l">
-              <a:defRPr sz="1400" b="0" i="0">
-                <a:solidFill>
-                  <a:srgbClr val="E2E2EA"/>
-                </a:solidFill>
-                <a:latin typeface="Calibri"/>
-              </a:defRPr>
-            </a:pPr>
-            <a:r>
-              <a:t>Revolutionary deployment service now available to all teams — deploy applications in just a few clicks with comprehensive security guidelines</a:t>
-            </a:r>
-          </a:p>
-        </p:txBody>
-      </p:sp>
-      <p:sp>
-        <p:nvSpPr>
-          <p:cNvPr id="10" name="TextBox 9"/>
-          <p:cNvSpPr txBox="1"/>
-          <p:nvPr/>
-        </p:nvSpPr>
-        <p:spPr>
-          <a:xfrm>
-            <a:off x="1097280" y="5486400"/>
-            <a:ext cx="9966960" cy="457200"/>
-          </a:xfrm>
-          <a:prstGeom prst="rect">
-            <a:avLst/>
-          </a:prstGeom>
-          <a:noFill/>
-        </p:spPr>
-        <p:txBody>
-          <a:bodyPr wrap="square">
-            <a:spAutoFit/>
-          </a:bodyPr>
-          <a:lstStyle/>
-          <a:p>
-            <a:pPr algn="l">
-              <a:defRPr sz="1300" b="0" i="1">
-                <a:solidFill>
-                  <a:srgbClr val="8F95A3"/>
-                </a:solidFill>
-                <a:latin typeface="Calibri"/>
-              </a:defRPr>
-            </a:pPr>
-            <a:r>
-              <a:t>💬 "Empowering non-engineering teams to build and deploy faster than ever"</a:t>
+              <a:defRPr sz="1200" b="1" i="0">
+                <a:solidFill>
+                  <a:srgbClr val="EF4444"/>
+                </a:solidFill>
+                <a:latin typeface="Calibri"/>
+              </a:defRPr>
+            </a:pPr>
+            <a:r>
+              <a:t>Excellence · Leadership</a:t>
             </a:r>
           </a:p>
         </p:txBody>
@@ -8261,7 +9085,7 @@
             <a:avLst/>
           </a:prstGeom>
           <a:solidFill>
-            <a:srgbClr val="42A5F5"/>
+            <a:srgbClr val="8B5CF6"/>
           </a:solidFill>
           <a:ln>
             <a:noFill/>
@@ -8314,13 +9138,13 @@
             <a:pPr algn="l">
               <a:defRPr sz="1000" b="1">
                 <a:solidFill>
-                  <a:srgbClr val="42A5F5"/>
-                </a:solidFill>
-                <a:latin typeface="Calibri"/>
-              </a:defRPr>
-            </a:pPr>
-            <a:r>
-              <a:t>🤖  WIN</a:t>
+                  <a:srgbClr val="8B5CF6"/>
+                </a:solidFill>
+                <a:latin typeface="Calibri"/>
+              </a:defRPr>
+            </a:pPr>
+            <a:r>
+              <a:t>⭐  CLAPS</a:t>
             </a:r>
           </a:p>
         </p:txBody>
@@ -8350,13 +9174,13 @@
             <a:pPr algn="l">
               <a:defRPr sz="3200" b="1" i="0">
                 <a:solidFill>
-                  <a:srgbClr val="42A5F5"/>
-                </a:solidFill>
-                <a:latin typeface="Calibri"/>
-              </a:defRPr>
-            </a:pPr>
-            <a:r>
-              <a:t>AI Revolution</a:t>
+                  <a:srgbClr val="8B5CF6"/>
+                </a:solidFill>
+                <a:latin typeface="Calibri"/>
+              </a:defRPr>
+            </a:pPr>
+            <a:r>
+              <a:t>Product Excellence</a:t>
             </a:r>
           </a:p>
         </p:txBody>
@@ -8370,29 +9194,29 @@
         <p:spPr>
           <a:xfrm>
             <a:off x="1097280" y="2103120"/>
-            <a:ext cx="4572000" cy="822960"/>
-          </a:xfrm>
-          <a:prstGeom prst="rect">
-            <a:avLst/>
-          </a:prstGeom>
-          <a:noFill/>
-        </p:spPr>
-        <p:txBody>
-          <a:bodyPr wrap="square">
-            <a:spAutoFit/>
-          </a:bodyPr>
-          <a:lstStyle/>
-          <a:p>
-            <a:pPr algn="l">
-              <a:defRPr sz="4800" b="1" i="0">
-                <a:solidFill>
-                  <a:srgbClr val="42A5F5"/>
-                </a:solidFill>
-                <a:latin typeface="Calibri"/>
-              </a:defRPr>
-            </a:pPr>
-            <a:r>
-              <a:t>100%</a:t>
+            <a:ext cx="2743200" cy="548640"/>
+          </a:xfrm>
+          <a:prstGeom prst="rect">
+            <a:avLst/>
+          </a:prstGeom>
+          <a:noFill/>
+        </p:spPr>
+        <p:txBody>
+          <a:bodyPr wrap="square">
+            <a:spAutoFit/>
+          </a:bodyPr>
+          <a:lstStyle/>
+          <a:p>
+            <a:pPr algn="l">
+              <a:defRPr sz="2800" b="1" i="0">
+                <a:solidFill>
+                  <a:srgbClr val="8B5CF6"/>
+                </a:solidFill>
+                <a:latin typeface="Calibri"/>
+              </a:defRPr>
+            </a:pPr>
+            <a:r>
+              <a:t>50</a:t>
             </a:r>
           </a:p>
         </p:txBody>
@@ -8405,30 +9229,30 @@
         </p:nvSpPr>
         <p:spPr>
           <a:xfrm>
-            <a:off x="1097280" y="2834640"/>
-            <a:ext cx="4572000" cy="365760"/>
-          </a:xfrm>
-          <a:prstGeom prst="rect">
-            <a:avLst/>
-          </a:prstGeom>
-          <a:noFill/>
-        </p:spPr>
-        <p:txBody>
-          <a:bodyPr wrap="square">
-            <a:spAutoFit/>
-          </a:bodyPr>
-          <a:lstStyle/>
-          <a:p>
-            <a:pPr algn="l">
-              <a:defRPr sz="1200" b="0" i="0">
-                <a:solidFill>
-                  <a:srgbClr val="8F95A3"/>
-                </a:solidFill>
-                <a:latin typeface="Calibri"/>
-              </a:defRPr>
-            </a:pPr>
-            <a:r>
-              <a:t>AI-powered</a:t>
+            <a:off x="1097280" y="2651760"/>
+            <a:ext cx="9966960" cy="365760"/>
+          </a:xfrm>
+          <a:prstGeom prst="rect">
+            <a:avLst/>
+          </a:prstGeom>
+          <a:noFill/>
+        </p:spPr>
+        <p:txBody>
+          <a:bodyPr wrap="square">
+            <a:spAutoFit/>
+          </a:bodyPr>
+          <a:lstStyle/>
+          <a:p>
+            <a:pPr algn="l">
+              <a:defRPr sz="1400" b="0" i="0">
+                <a:solidFill>
+                  <a:srgbClr val="E2E2EA"/>
+                </a:solidFill>
+                <a:latin typeface="Calibri"/>
+              </a:defRPr>
+            </a:pPr>
+            <a:r>
+              <a:t>from Jasmine Nunez</a:t>
             </a:r>
           </a:p>
         </p:txBody>
@@ -8441,7 +9265,7 @@
         </p:nvSpPr>
         <p:spPr>
           <a:xfrm>
-            <a:off x="1097280" y="3291840"/>
+            <a:off x="1097280" y="3108960"/>
             <a:ext cx="9966960" cy="365760"/>
           </a:xfrm>
           <a:prstGeom prst="rect">
@@ -8456,7 +9280,43 @@
           <a:lstStyle/>
           <a:p>
             <a:pPr algn="l">
-              <a:defRPr sz="1400" b="0" i="0">
+              <a:defRPr sz="1400" b="1" i="0">
+                <a:solidFill>
+                  <a:srgbClr val="FFFFFF"/>
+                </a:solidFill>
+                <a:latin typeface="Calibri"/>
+              </a:defRPr>
+            </a:pPr>
+            <a:r>
+              <a:t>to: Michelle Walter</a:t>
+            </a:r>
+          </a:p>
+        </p:txBody>
+      </p:sp>
+      <p:sp>
+        <p:nvSpPr>
+          <p:cNvPr id="8" name="TextBox 7"/>
+          <p:cNvSpPr txBox="1"/>
+          <p:nvPr/>
+        </p:nvSpPr>
+        <p:spPr>
+          <a:xfrm>
+            <a:off x="1097280" y="3749039"/>
+            <a:ext cx="9966960" cy="1097280"/>
+          </a:xfrm>
+          <a:prstGeom prst="rect">
+            <a:avLst/>
+          </a:prstGeom>
+          <a:noFill/>
+        </p:spPr>
+        <p:txBody>
+          <a:bodyPr wrap="square">
+            <a:spAutoFit/>
+          </a:bodyPr>
+          <a:lstStyle/>
+          <a:p>
+            <a:pPr algn="l">
+              <a:defRPr sz="1500" b="0" i="1">
                 <a:solidFill>
                   <a:srgbClr val="E2E2EA"/>
                 </a:solidFill>
@@ -8464,20 +9324,20 @@
               </a:defRPr>
             </a:pPr>
             <a:r>
-              <a:t>by Liliya Garifullina</a:t>
-            </a:r>
-          </a:p>
-        </p:txBody>
-      </p:sp>
-      <p:sp>
-        <p:nvSpPr>
-          <p:cNvPr id="8" name="TextBox 7"/>
-          <p:cNvSpPr txBox="1"/>
-          <p:nvPr/>
-        </p:nvSpPr>
-        <p:spPr>
-          <a:xfrm>
-            <a:off x="1097280" y="3840480"/>
+              <a:t>"Outstanding product management and delivery"</a:t>
+            </a:r>
+          </a:p>
+        </p:txBody>
+      </p:sp>
+      <p:sp>
+        <p:nvSpPr>
+          <p:cNvPr id="9" name="TextBox 8"/>
+          <p:cNvSpPr txBox="1"/>
+          <p:nvPr/>
+        </p:nvSpPr>
+        <p:spPr>
+          <a:xfrm>
+            <a:off x="1097280" y="5120640"/>
             <a:ext cx="9966960" cy="457200"/>
           </a:xfrm>
           <a:prstGeom prst="rect">
@@ -8492,87 +9352,15 @@
           <a:lstStyle/>
           <a:p>
             <a:pPr algn="l">
-              <a:defRPr sz="1800" b="1" i="0">
-                <a:solidFill>
-                  <a:srgbClr val="FFFFFF"/>
-                </a:solidFill>
-                <a:latin typeface="Calibri"/>
-              </a:defRPr>
-            </a:pPr>
-            <a:r>
-              <a:t>Zero-Code AI Dashboard Success</a:t>
-            </a:r>
-          </a:p>
-        </p:txBody>
-      </p:sp>
-      <p:sp>
-        <p:nvSpPr>
-          <p:cNvPr id="9" name="TextBox 8"/>
-          <p:cNvSpPr txBox="1"/>
-          <p:nvPr/>
-        </p:nvSpPr>
-        <p:spPr>
-          <a:xfrm>
-            <a:off x="1097280" y="4389120"/>
-            <a:ext cx="9966960" cy="914400"/>
-          </a:xfrm>
-          <a:prstGeom prst="rect">
-            <a:avLst/>
-          </a:prstGeom>
-          <a:noFill/>
-        </p:spPr>
-        <p:txBody>
-          <a:bodyPr wrap="square">
-            <a:spAutoFit/>
-          </a:bodyPr>
-          <a:lstStyle/>
-          <a:p>
-            <a:pPr algn="l">
-              <a:defRPr sz="1400" b="0" i="0">
-                <a:solidFill>
-                  <a:srgbClr val="E2E2EA"/>
-                </a:solidFill>
-                <a:latin typeface="Calibri"/>
-              </a:defRPr>
-            </a:pPr>
-            <a:r>
-              <a:t>Built fully automated AI system from Slack data to live office TV dashboard using only AI tools — no coding required</a:t>
-            </a:r>
-          </a:p>
-        </p:txBody>
-      </p:sp>
-      <p:sp>
-        <p:nvSpPr>
-          <p:cNvPr id="10" name="TextBox 9"/>
-          <p:cNvSpPr txBox="1"/>
-          <p:nvPr/>
-        </p:nvSpPr>
-        <p:spPr>
-          <a:xfrm>
-            <a:off x="1097280" y="5486400"/>
-            <a:ext cx="9966960" cy="457200"/>
-          </a:xfrm>
-          <a:prstGeom prst="rect">
-            <a:avLst/>
-          </a:prstGeom>
-          <a:noFill/>
-        </p:spPr>
-        <p:txBody>
-          <a:bodyPr wrap="square">
-            <a:spAutoFit/>
-          </a:bodyPr>
-          <a:lstStyle/>
-          <a:p>
-            <a:pPr algn="l">
-              <a:defRPr sz="1300" b="0" i="1">
-                <a:solidFill>
-                  <a:srgbClr val="8F95A3"/>
-                </a:solidFill>
-                <a:latin typeface="Calibri"/>
-              </a:defRPr>
-            </a:pPr>
-            <a:r>
-              <a:t>💬 "Proof that our AI-first future is already here — if she can do it, you can too!"</a:t>
+              <a:defRPr sz="1200" b="1" i="0">
+                <a:solidFill>
+                  <a:srgbClr val="8B5CF6"/>
+                </a:solidFill>
+                <a:latin typeface="Calibri"/>
+              </a:defRPr>
+            </a:pPr>
+            <a:r>
+              <a:t>Excellence · Results</a:t>
             </a:r>
           </a:p>
         </p:txBody>

</xml_diff>